<commit_message>
Fill in author name on D6 report and presentation
Replace the [Your Name] placeholder with Abdurrahmaan Ali on the
final report's title page and the presentation's title slide (both
the on-screen text and the speaker notes narration), then
regenerated the presentation video and its captions to match.

Co-Authored-By: Claude Sonnet 5 <noreply@anthropic.com>
Claude-Session: https://claude.ai/code/session_01BLVAgZrQBMgC6fgji1xmot
</commit_message>
<xml_diff>
--- a/docs/ABDURRAHMAAN_IT401_DEL_6_PRESENTATION.pptx
+++ b/docs/ABDURRAHMAAN_IT401_DEL_6_PRESENTATION.pptx
@@ -792,7 +792,7 @@
           <a:p>
             <a:r>
               <a:rPr lang="en-US" dirty="0"/>
-              <a:t>Good [morning/afternoon]. My name is [Your Name], and today I'm presenting RentalPro, a Digital Rental Management System built as my IT401 capstone project. Over the next few minutes I'll walk through the problem this system solves, how it was designed and built, and the results of testing it — including a live demo of the working application. All five project deliverables — requirements, design, the working prototype, the full project report, and 100% feature completion — are finished, tested, and documented.</a:t>
+              <a:t>Good [morning/afternoon]. My name is Abdurrahmaan Ali, and today I'm presenting RentalPro, a Digital Rental Management System built as my IT401 capstone project. Over the next few minutes I'll walk through the problem this system solves, how it was designed and built, and the results of testing it — including a live demo of the working application. All five project deliverables — requirements, design, the working prototype, the full project report, and 100% feature completion — are finished, tested, and documented.</a:t>
             </a:r>
             <a:endParaRPr lang="en-US" dirty="0"/>
           </a:p>
@@ -2646,7 +2646,7 @@
                 <a:ea typeface="Calibri" pitchFamily="34" charset="-122"/>
                 <a:cs typeface="Calibri" pitchFamily="34" charset="-120"/>
               </a:rPr>
-              <a:t>Presented by: [Your Name]</a:t>
+              <a:t>Presented by: Abdurrahmaan Ali</a:t>
             </a:r>
             <a:endParaRPr lang="en-US" sz="1300" dirty="0"/>
           </a:p>

</xml_diff>

<commit_message>
Update the D6 deck, both videos and the walkthrough for Arabic
- Presentation: slide text, chart (Map & i18n 17 -> 22) and speaker
  notes cover English, Shona and Arabic and the language menu; the
  New Look slide now shows the login page with the menu open and the
  tenant portal in Arabic, right to left
- Presentation video rebuilt from the updated slides and notes (15:14,
  narration subtitles)
- Demo video re-recorded: the language menu, Shona, Arabic right to
  left, the choice surviving log-out, the tenant portal in Shona and
  back to English (1:48, captions)
- UI walkthrough PDF: login with the menu open, updated captions, and
  two new Arabic pages (admin and tenant dashboards) — 19 pages

Co-Authored-By: Claude Opus 5.5 <noreply@anthropic.com>
Claude-Session: https://claude.ai/code/session_01BLVAgZrQBMgC6fgji1xmot
</commit_message>
<xml_diff>
--- a/docs/ABDURRAHMAAN_IT401_DEL_6_PRESENTATION.pptx
+++ b/docs/ABDURRAHMAAN_IT401_DEL_6_PRESENTATION.pptx
@@ -272,7 +272,7 @@
                   <c:v>79</c:v>
                 </c:pt>
                 <c:pt idx="7">
-                  <c:v>17</c:v>
+                  <c:v>22</c:v>
                 </c:pt>
               </c:numCache>
             </c:numRef>
@@ -807,7 +807,7 @@
           <a:p>
             <a:r>
               <a:rPr lang="en-US" dirty="0"/>
-              <a:t>Hello. My name is Abdurrahmaan Ali, and today I'm presenting RentalPro, a Digital Rental Management System built as my IT401 capstone project. Over the next few minutes I'll walk through the problem this system solves, how it was designed and built, and the results of testing it — including a live demo of the working application. All six project deliverables — requirements, design, the working prototype, the full project report, 100% feature completion, and the final demo and presentation package — are finished, tested, and documented. Since then, I've also extended the system with a full billing engine, and made it more usable for Harare landlords and tenants, including an English and Shona language switch — I'll cover both.</a:t>
+              <a:t>Hello. My name is Abdurrahmaan Ali, and today I'm presenting RentalPro, a Digital Rental Management System built as my IT401 capstone project. Over the next few minutes I'll walk through the problem this system solves, how it was designed and built, and the results of testing it — including a live demo of the working application. All six project deliverables — requirements, design, the working prototype, the full project report, 100% feature completion, and the final demo and presentation package — are finished, tested, and documented. Since then, I've also extended the system with a full billing engine, and made it more usable for Harare landlords and tenants, including a choice of English, Shona and Arabic — I'll cover both.</a:t>
             </a:r>
             <a:endParaRPr lang="en-US" dirty="0"/>
           </a:p>
@@ -895,7 +895,7 @@
           <a:p>
             <a:r>
               <a:rPr lang="en-US" dirty="0"/>
-              <a:t>This is the slide that backs up every claim in this presentation. 226 automated tests, zero failures, 82 percent statement coverage across the backend, and all 25 use cases from the SRS covered by at least one test. The chart breaks that down by module — 36 validation tests, 31 for Deliverable 5's feature gaps, 79 for the billing engine alone, the single largest block in the project, and 17 for the property map and the English and Shona switch. Importantly, these aren't unit tests calling isolated functions — they go through Flask's real test client, issuing actual HTTP requests through session handling, CSRF, RBAC, and the ORM. That's how a real security bug like cross-owner data access — one Property Owner querying another Owner's property — gets caught before it ships, not after.</a:t>
+              <a:t>This is the slide that backs up every claim in this presentation. 231 automated tests, zero failures, 82 percent statement coverage across the backend, and all 25 use cases from the SRS covered by at least one test. The chart breaks that down by module — 36 validation tests, 31 for Deliverable 5's feature gaps, 79 for the billing engine alone, the single largest block in the project, and 22 for the property map and the three languages. Importantly, these aren't unit tests calling isolated functions — they go through Flask's real test client, issuing actual HTTP requests through session handling, CSRF, RBAC, and the ORM. That's how a real security bug like cross-owner data access — one Property Owner querying another Owner's property — gets caught before it ships, not after.</a:t>
             </a:r>
             <a:endParaRPr lang="en-US" dirty="0"/>
           </a:p>
@@ -983,7 +983,7 @@
           <a:p>
             <a:r>
               <a:rPr lang="en-US" dirty="0"/>
-              <a:t>Now let's see it running. I'll walk through six things: first, an Owner setting up a property and unit with photos and a configured late fee. Second, onboarding a new tenant, uploading their lease, and watching the unit activate. Third, the Deliverable 5 blacklist toggle and recording a rent payment. Fourth, a full maintenance ticket lifecycle rotating through four different role logins — tenant submits, owner assigns, staff completes, tenant confirms. Fifth, the admin console for user management and creating a new staff account. And finally, the billing engine end to end — charges, metering, pro rata, a rent revision, the automated billing job's paper trail, a filtered account statement, a downloaded payment receipt, and a property expense feeding into net income — and to finish, the Harare portfolio on the map and the whole interface switching to Shona and back. [Switch to the recorded demo video or live application here.]</a:t>
+              <a:t>Now let's see it running. I'll walk through six things: first, an Owner setting up a property and unit with photos and a configured late fee. Second, onboarding a new tenant, uploading their lease, and watching the unit activate. Third, the Deliverable 5 blacklist toggle and recording a rent payment. Fourth, a full maintenance ticket lifecycle rotating through four different role logins — tenant submits, owner assigns, staff completes, tenant confirms. Fifth, the admin console for user management and creating a new staff account. And finally, the billing engine end to end — charges, metering, pro rata, a rent revision, the automated billing job's paper trail, a filtered account statement, a downloaded payment receipt, and a property expense feeding into net income — and to finish, the Harare portfolio on the map and the whole interface switching to Shona, then to Arabic, laid out right to left, and back to English. [Switch to the recorded demo video or live application here.]</a:t>
             </a:r>
             <a:endParaRPr lang="en-US" dirty="0"/>
           </a:p>
@@ -1247,7 +1247,7 @@
           <a:p>
             <a:r>
               <a:rPr lang="en-US" dirty="0"/>
-              <a:t>To wrap up: RentalPro went from a requirements document, through design, to a working prototype, a full seven-chapter project report, 100% feature completion, an extended billing engine, and now a localised interface for Harare — and every number on this slide was produced by actually running the code, not estimated. 25 of 25 use cases, each with a route and a covering test. The 13-table design implemented exactly as specified. 226 tests, zero failures, 82 percent coverage. Eight feature gaps closed in Deliverable 5, eight more billing capabilities added since, and an English and Shona interface. And the whole thing runs fully offline, with zero paid external accounts required to build or test it. That discipline — that a claim in the report is a fact about the system, not a target for it — is, I'd argue, as much a deliverable of this capstone as the application itself.</a:t>
+              <a:t>To wrap up: RentalPro went from a requirements document, through design, to a working prototype, a full seven-chapter project report, 100% feature completion, an extended billing engine, and now a localised interface for Harare — and every number on this slide was produced by actually running the code, not estimated. 25 of 25 use cases, each with a route and a covering test. The 13-table design implemented exactly as specified. 231 tests, zero failures, 82 percent coverage. Eight feature gaps closed in Deliverable 5, eight more billing capabilities added since, and an interface in English, Shona and Arabic. And the whole thing runs fully offline, with zero paid external accounts required to build or test it. That discipline — that a claim in the report is a fact about the system, not a target for it — is, I'd argue, as much a deliverable of this capstone as the application itself.</a:t>
             </a:r>
             <a:endParaRPr lang="en-US" dirty="0"/>
           </a:p>
@@ -1335,7 +1335,7 @@
           <a:p>
             <a:r>
               <a:rPr lang="en-US" dirty="0"/>
-              <a:t>Looking ahead to Part 2 of the capstone: cloud file storage is the natural next step — and because photo and document storage is already isolated behind a small storage.py interface, that swap needs no changes to routes or templates. A mobile-optimized tenant portal is next, since tenants are the role most likely to use this from a phone. Alembic-based schema migrations would replace the create_all() bootstrap I used during development, which is fine pre-launch but not for a live database holding real tenant data. And finally, end-to-end verification against live Stripe, SendGrid, and Twilio sandbox accounts, on top of the offline test suite that's carried the project so far. And last, finishing the Shona translation for the remaining screens and messages, and having a native speaker review the wording.</a:t>
+              <a:t>Looking ahead to Part 2 of the capstone: cloud file storage is the natural next step — and because photo and document storage is already isolated behind a small storage.py interface, that swap needs no changes to routes or templates. A mobile-optimized tenant portal is next, since tenants are the role most likely to use this from a phone. Alembic-based schema migrations would replace the create_all() bootstrap I used during development, which is fine pre-launch but not for a live database holding real tenant data. And finally, end-to-end verification against live Stripe, SendGrid, and Twilio sandbox accounts, on top of the offline test suite that's carried the project so far. And last, finishing the Shona and Arabic translations for the remaining screens and messages, and having native speakers review the wording.</a:t>
             </a:r>
             <a:endParaRPr lang="en-US" dirty="0"/>
           </a:p>
@@ -1511,7 +1511,7 @@
           <a:p>
             <a:r>
               <a:rPr lang="en-US" dirty="0"/>
-              <a:t>The most recent round of work was about the people who would actually use RentalPro — landlords, managers and tenants in Harare. Every property can now carry map coordinates, set by clicking a map, and there's a portfolio map showing all of them. The interface moved from a sidebar to a horizontal top bar, and the login page and each section of the app now show photographs of Harare. The biggest change is a language switch: EN or SN, English or Shona, from the top bar or the login page, and the choice sticks when you log in and out. My SRS originally described Arabic and English; because the users are in Harare, Shona was the right second language, and the mechanism works for any language. Only interface text is translated — names and places stay exactly as entered, and a test fails if that ever changes. Tenants now see their unit as 'Avondale Heights, Unit 101' rather than an internal code, a blank-page bug for signed-in users is fixed, and the demo data is now a realistic Harare portfolio: five properties, sixteen units and nine tenants. Twenty-two new tests cover this work.</a:t>
+              <a:t>The most recent round of work was about the people who would actually use RentalPro — landlords, managers and tenants in Harare. Every property can now carry map coordinates, set by clicking a map, and there's a portfolio map showing all of them. The interface moved from a sidebar to a horizontal top bar, and the login page and each section of the app now show photographs of Harare. The biggest change is language: a menu in the top bar and on the login page offers English, Shona and Arabic, and the choice sticks when you log in and out. My SRS originally described Arabic and English; both are now in, and because the users are in Harare, I added Shona as well. Arabic is written right to left, so an Arabic page mirrors the whole layout. Only interface text is translated — names and places stay exactly as entered, and a test fails if that ever changes. Tenants now see their unit as 'Avondale Heights, Unit 101' rather than an internal code, a blank-page bug for signed-in users is fixed, and the demo data is now a realistic Harare portfolio: five properties, sixteen units and nine tenants. Twenty-seven new tests cover this work.</a:t>
             </a:r>
           </a:p>
         </p:txBody>
@@ -1598,7 +1598,7 @@
           <a:p>
             <a:r>
               <a:rPr lang="en-US" dirty="0"/>
-              <a:t>Here's what that looks like. On the left is the login page: a full-screen photograph of the Harare skyline, a translucent sign-in card, and the EN, SN switch in the corner. On the right is a tenant's dashboard after switching to Shona — 'Mauya', welcome, her unit shown as Avondale Heights, Yuniti 101, her balance, and the button to pay rent. The property name stays in English, because it's a name, not interface text.</a:t>
+              <a:t>Here's what that looks like. On the left is the login page: a full-screen photograph of the Harare skyline, a translucent sign-in card, and the language menu open in the corner, offering English, ChiShona and Arabic. On the right is a tenant's dashboard in Arabic. The whole layout reads right to left — the navigation starts on the right, and the cards and tables are mirrored — with a welcome, her unit, her balance, and the button to pay rent. Her name and 'Avondale Heights' stay exactly as entered, because they're data, not interface text.</a:t>
             </a:r>
           </a:p>
         </p:txBody>
@@ -2037,7 +2037,7 @@
           <a:p>
             <a:r>
               <a:rPr lang="en-US" dirty="0"/>
-              <a:t>The application is a layered Flask monolith — deliberately simplified from Deliverable 2's more ambitious microservice sketch, because a single developer needed to build and verify it in the time available. Presentation is 38 Jinja2 templates behind a role-aware top navigation bar, with an English and Shona switch. The application layer is 10 Flask Blueprints — one each for auth, properties, tenants, rent, maintenance, admin, reports, the tenant portal, and the REST API. Below that, the domain and service layer holds security.py for RBAC and IDOR protection, the five scheduler jobs, a small translation module for English and Shona,, and a services package for PDF generation, Excel export, notifications, and payments. Data is 18 SQLAlchemy models — the 13 from the design plus 5 for the billing engine — with UUID keys. And infrastructure is Docker Compose running PostgreSQL and Redis, with a dev-mode fallback for every paid external service — which is what let me build and test this entire system without a single paid account.</a:t>
+              <a:t>The application is a layered Flask monolith — deliberately simplified from Deliverable 2's more ambitious microservice sketch, because a single developer needed to build and verify it in the time available. Presentation is 38 Jinja2 templates behind a role-aware top navigation bar, with a language menu for English, Shona and Arabic. The application layer is 10 Flask Blueprints — one each for auth, properties, tenants, rent, maintenance, admin, reports, the tenant portal, and the REST API. Below that, the domain and service layer holds security.py for RBAC and IDOR protection, the five scheduler jobs, a small translation module for Shona and Arabic, which also turns Arabic pages right to left, and a services package for PDF generation, Excel export, notifications, and payments. Data is 18 SQLAlchemy models — the 13 from the design plus 5 for the billing engine — with UUID keys. And infrastructure is Docker Compose running PostgreSQL and Redis, with a dev-mode fallback for every paid external service — which is what let me build and test this entire system without a single paid account.</a:t>
             </a:r>
             <a:endParaRPr lang="en-US" dirty="0"/>
           </a:p>
@@ -2858,7 +2858,7 @@
                 <a:ea typeface="Calibri" pitchFamily="34" charset="-122"/>
                 <a:cs typeface="Calibri" pitchFamily="34" charset="-120"/>
               </a:rPr>
-              <a:t>IT401 Capstone Project Defense  ·  Deliverables 1–6 Complete + Billing Engine + English/Shona</a:t>
+              <a:t>IT401 Capstone Project Defense  ·  Deliverables 1–6 Complete + Billing Engine + English/Shona/Arabic</a:t>
             </a:r>
             <a:endParaRPr lang="en-US" sz="1500" dirty="0"/>
           </a:p>
@@ -3068,7 +3068,7 @@
                 <a:ea typeface="Cambria" pitchFamily="34" charset="-122"/>
                 <a:cs typeface="Cambria" pitchFamily="34" charset="-120"/>
               </a:rPr>
-              <a:t>226</a:t>
+              <a:t>231</a:t>
             </a:r>
             <a:endParaRPr lang="en-US" sz="3400" dirty="0"/>
           </a:p>
@@ -4575,7 +4575,7 @@
                 <a:ea typeface="Calibri" pitchFamily="34" charset="-122"/>
                 <a:cs typeface="Calibri" pitchFamily="34" charset="-120"/>
               </a:rPr>
-              <a:t>Billing engine, then the Harare map and the EN | SN switch</a:t>
+              <a:t>Billing engine, then the Harare map and the language menu</a:t>
             </a:r>
             <a:endParaRPr lang="en-US" sz="1350" dirty="0"/>
           </a:p>
@@ -7213,7 +7213,7 @@
                 <a:ea typeface="Calibri" pitchFamily="34" charset="-122"/>
                 <a:cs typeface="Calibri" pitchFamily="34" charset="-120"/>
               </a:rPr>
-              <a:t>226 automated tests, 0 failures, 82% statement coverage</a:t>
+              <a:t>231 automated tests, 0 failures, 82% statement coverage</a:t>
             </a:r>
             <a:endParaRPr lang="en-US" sz="1400" dirty="0"/>
           </a:p>
@@ -7311,7 +7311,7 @@
                 <a:ea typeface="Calibri" pitchFamily="34" charset="-122"/>
                 <a:cs typeface="Calibri" pitchFamily="34" charset="-120"/>
               </a:rPr>
-              <a:t>8 feature gaps closed in Deliverable 5, a billing engine, and an English/Shona interface</a:t>
+              <a:t>8 feature gaps closed in Deliverable 5, a billing engine, and an English/Shona/Arabic interface</a:t>
             </a:r>
             <a:endParaRPr lang="en-US" sz="1400" dirty="0"/>
           </a:p>
@@ -8417,7 +8417,7 @@
                 <a:ea typeface="Calibri" pitchFamily="34" charset="-122"/>
                 <a:cs typeface="Calibri" pitchFamily="34" charset="-120"/>
               </a:rPr>
-              <a:t>Complete the Shona translation</a:t>
+              <a:t>Complete the translations</a:t>
             </a:r>
             <a:endParaRPr lang="en-US" sz="1450" dirty="0"/>
           </a:p>
@@ -8456,7 +8456,7 @@
                 <a:ea typeface="Calibri" pitchFamily="34" charset="-122"/>
                 <a:cs typeface="Calibri" pitchFamily="34" charset="-120"/>
               </a:rPr>
-              <a:t>Translate the remaining forms and messages, and have a native Shona speaker check the wording</a:t>
+              <a:t>Translate the remaining forms and messages into Shona and Arabic, and have native speakers check the wording</a:t>
             </a:r>
             <a:endParaRPr lang="en-US" sz="1200" dirty="0"/>
           </a:p>
@@ -8833,7 +8833,7 @@
                 <a:ea typeface="Calibri" pitchFamily="34" charset="-122"/>
                 <a:cs typeface="Calibri" pitchFamily="34" charset="-120"/>
               </a:rPr>
-              <a:t>Built for Harare: a clearer interface, a second language and realistic local data — 22 more tests, all passing.</a:t>
+              <a:t>Built for Harare: a clearer interface, two more languages and realistic local data — 27 more tests, all passing.</a:t>
             </a:r>
             <a:endParaRPr lang="en-US" sz="1350" dirty="0"/>
           </a:p>
@@ -9430,7 +9430,7 @@
                 <a:ea typeface="Calibri" pitchFamily="34" charset="-122"/>
                 <a:cs typeface="Calibri" pitchFamily="34" charset="-120"/>
               </a:rPr>
-              <a:t>English / Shona switch</a:t>
+              <a:t>English, Shona &amp; Arabic</a:t>
             </a:r>
             <a:endParaRPr lang="en-US" sz="1300" dirty="0"/>
           </a:p>
@@ -9469,7 +9469,7 @@
                 <a:ea typeface="Calibri" pitchFamily="34" charset="-122"/>
                 <a:cs typeface="Calibri" pitchFamily="34" charset="-120"/>
               </a:rPr>
-              <a:t>An EN | SN toggle in the top bar and on login; the choice survives logging in and out</a:t>
+              <a:t>A language menu in the top bar and on login; Arabic reads right to left; the choice is remembered</a:t>
             </a:r>
             <a:endParaRPr lang="en-US" sz="1000" dirty="0"/>
           </a:p>
@@ -10254,7 +10254,7 @@
                 <a:ea typeface="Cambria" pitchFamily="34" charset="-122"/>
                 <a:cs typeface="Cambria" pitchFamily="34" charset="-120"/>
               </a:rPr>
-              <a:t>The New Look — Harare &amp; Shona</a:t>
+              <a:t>The New Look — Harare, Shona &amp; Arabic</a:t>
             </a:r>
             <a:endParaRPr lang="en-US" sz="4800" dirty="0"/>
           </a:p>
@@ -10293,7 +10293,7 @@
                 <a:ea typeface="Calibri" pitchFamily="34" charset="-122"/>
                 <a:cs typeface="Calibri" pitchFamily="34" charset="-120"/>
               </a:rPr>
-              <a:t>The Harare login page, and the tenant portal switched to Shona</a:t>
+              <a:t>The Harare login page with its language menu, and the tenant portal in Arabic</a:t>
             </a:r>
             <a:endParaRPr lang="en-US" sz="1600" dirty="0"/>
           </a:p>
@@ -10379,7 +10379,7 @@
       </p:sp>
       <p:pic>
         <p:nvPicPr>
-          <p:cNvPr id="60" name="Login screenshot" descr="RentalPro login page over a photo of the Harare skyline, with an EN | SN switch"/>
+          <p:cNvPr id="60" name="Login screenshot" descr="RentalPro login page over a photo of the Harare skyline, with the language menu open"/>
           <p:cNvPicPr>
             <a:picLocks noChangeAspect="1"/>
           </p:cNvPicPr>
@@ -10408,7 +10408,7 @@
       </p:pic>
       <p:pic>
         <p:nvPicPr>
-          <p:cNvPr id="61" name="Shona tenant portal screenshot" descr="Tenant dashboard in Shona for Chipo Mutasa"/>
+          <p:cNvPr id="61" name="Arabic tenant portal screenshot" descr="Tenant dashboard in Arabic, right to left, for Chipo Mutasa"/>
           <p:cNvPicPr>
             <a:picLocks noChangeAspect="1"/>
           </p:cNvPicPr>
@@ -10473,14 +10473,14 @@
                 </a:solidFill>
                 <a:latin typeface="Calibri"/>
               </a:rPr>
-              <a:t>A full-screen Harare skyline, a translucent card, and the EN | SN switch top-right</a:t>
-            </a:r>
-          </a:p>
-        </p:txBody>
-      </p:sp>
-      <p:sp>
-        <p:nvSpPr>
-          <p:cNvPr id="63" name="Shona caption"/>
+              <a:t>A full-screen Harare skyline, a translucent card, and the language menu open top-right</a:t>
+            </a:r>
+          </a:p>
+        </p:txBody>
+      </p:sp>
+      <p:sp>
+        <p:nvSpPr>
+          <p:cNvPr id="63" name="Arabic caption"/>
           <p:cNvSpPr txBox="1"/>
           <p:nvPr/>
         </p:nvSpPr>
@@ -10505,7 +10505,7 @@
                 </a:solidFill>
                 <a:latin typeface="Calibri"/>
               </a:rPr>
-              <a:t>Tenant portal in Shona</a:t>
+              <a:t>Tenant portal in Arabic</a:t>
             </a:r>
           </a:p>
           <a:p>
@@ -10516,7 +10516,7 @@
                 </a:solidFill>
                 <a:latin typeface="Calibri"/>
               </a:rPr>
-              <a:t>“Mauya” (welcome), the unit as “Avondale Heights · Yuniti 101”, and the pay-rent action</a:t>
+              <a:t>Laid out right to left — her name and “Avondale Heights” stay exactly as entered</a:t>
             </a:r>
           </a:p>
         </p:txBody>
@@ -15015,7 +15015,7 @@
                 <a:ea typeface="Calibri" pitchFamily="34" charset="-122"/>
                 <a:cs typeface="Calibri" pitchFamily="34" charset="-120"/>
               </a:rPr>
-              <a:t>38 Jinja2 templates, role-aware top navigation, English/Shona switch</a:t>
+              <a:t>38 Jinja2 templates, role-aware top navigation, English/Shona/Arabic menu</a:t>
             </a:r>
             <a:endParaRPr lang="en-US" sz="1150" dirty="0"/>
           </a:p>
@@ -15215,7 +15215,7 @@
                 <a:ea typeface="Calibri" pitchFamily="34" charset="-122"/>
                 <a:cs typeface="Calibri" pitchFamily="34" charset="-120"/>
               </a:rPr>
-              <a:t>security.py (RBAC, IDOR), i18n.py (English/Shona), scheduler_jobs.py, services/ (pdf, excel, notifications, payments, storage)</a:t>
+              <a:t>security.py (RBAC, IDOR), i18n.py (English/Shona/Arabic), scheduler_jobs.py, services/ (pdf, excel, notifications, payments, storage)</a:t>
             </a:r>
             <a:endParaRPr lang="en-US" sz="1150" dirty="0"/>
           </a:p>

</xml_diff>

<commit_message>
Make every deliverable record its own point in time, and agree on the facts
D3 and D4 had been rewritten after Deliverable 5 while still claiming to
record Deliverables 3 and 4. Each is now its original as-submitted text
(93 tests, 77% coverage, 31 templates), followed by one clearly marked
'Updates Since' section with a correct 'At Deliverable N' column and the
current figures. D3's table of contents now shows real page numbers.

The D6 report, deck and presentation video now count Deliverable 5's
gaps as eleven, matching the D5 report (unit editing and lease document
download had been left out). D5 shows the 77% coverage it had before
Deliverable 5, and no document says D3 or D4 were rewritten any more.

Co-Authored-By: Claude Opus 5.5 <noreply@anthropic.com>
Claude-Session: https://claude.ai/code/session_01Ae7GFufZcC1fFQLcjKeCLN
</commit_message>
<xml_diff>
--- a/docs/ABDURRAHMAAN_IT401_DEL_6_PRESENTATION.pptx
+++ b/docs/ABDURRAHMAAN_IT401_DEL_6_PRESENTATION.pptx
@@ -1251,7 +1251,7 @@
           <a:lstStyle/>
           <a:p>
             <a:r>
-              <a:t>To wrap up: RentalPro went from a requirements document, through design, to a working prototype, a full seven-chapter project report, 100% feature completion, an extended billing engine, a localised interface for Harare, and finally full Arabic and production hardening — and every number on this slide was produced by actually running the code, not estimated. 25 of 25 use cases, each with a route and a covering test. The 13-table design implemented exactly as specified. 298 tests, zero failures, 85 percent coverage. Eight feature gaps closed in Deliverable 5, eight more billing capabilities added since, and an interface in English, Shona and Arabic — with Arabic reaching every screen, message, email and PDF. And the whole thing runs fully offline, with zero paid external accounts required to build or test it. That discipline — that a claim in the report is a fact about the system, not a target for it — is, I'd argue, as much a deliverable of this capstone as the application itself.</a:t>
+              <a:t>To wrap up: RentalPro went from a requirements document, through design, to a working prototype, a full seven-chapter project report, 100% feature completion, an extended billing engine, a localised interface for Harare, and finally full Arabic and production hardening — and every number on this slide was produced by actually running the code, not estimated. 25 of 25 use cases, each with a route and a covering test. The 13-table design implemented exactly as specified. 298 tests, zero failures, 85 percent coverage. Eleven feature gaps closed in Deliverable 5, eight more billing capabilities added since, and an interface in English, Shona and Arabic — with Arabic reaching every screen, message, email and PDF. And the whole thing runs fully offline, with zero paid external accounts required to build or test it. That discipline — that a claim in the report is a fact about the system, not a target for it — is, I'd argue, as much a deliverable of this capstone as the application itself.</a:t>
             </a:r>
           </a:p>
         </p:txBody>
@@ -2281,10 +2281,8 @@
           <a:lstStyle/>
           <a:p>
             <a:r>
-              <a:rPr lang="en-US" dirty="0"/>
-              <a:t>Deliverable 5 is where the project went from working to 100% complete against the original requirements. Eight gaps were identified and closed: photo uploads for properties, units, and maintenance tickets, all validated by their actual file content, not just the extension; configurable late fees, fixed or percentage, applied automatically once rent is overdue; tenant blacklisting, which blocks a future lease without touching an existing one; tenant ID document upload; the admin user console, with a safety guard that won't let you remove the last active Owner; self-service staff account creation; and one-click CSV and Excel export for rent history and portfolio reporting. Every one of these eight is covered by its own test module, which I'll show numbers for next. When I later traced all 44 functional requirements one by one, two were only partly met — the full tenant history of each unit, and a maintenance summary by period — so I built both, and all 44 requirements are now met.</a:t>
-            </a:r>
-            <a:endParaRPr lang="en-US" dirty="0"/>
+              <a:t>Deliverable 5 is where the project went from working to 100% complete against the original requirements. An audit found eleven gaps, grouped on this slide into eight areas: photo uploads for properties, units, and maintenance tickets, all validated by their actual file content, not just the extension; editing a unit after it's created; configurable late fees, fixed or percentage, applied automatically once rent is overdue; tenant blacklisting, which blocks a future lease without touching an existing one; tenant ID documents and lease document downloads; the admin user console, with a safety guard that won't let you remove the last active Owner; self-service staff account creation; and one-click CSV and Excel exports. All eleven are covered by a dedicated 31-test module, which I'll show numbers for next. When I later traced all 44 functional requirements one by one, two were only partly met — the full tenant history of each unit, and a maintenance summary by period — so I built both, and all 44 requirements are now met.</a:t>
+            </a:r>
           </a:p>
         </p:txBody>
       </p:sp>
@@ -4563,6 +4561,1523 @@
 </file>
 
 <file path=ppt/slides/slide11.xml><?xml version="1.0" encoding="utf-8"?>
+<p:sld xmlns:a="http://schemas.openxmlformats.org/drawingml/2006/main" xmlns:p="http://schemas.openxmlformats.org/presentationml/2006/main" xmlns:r="http://schemas.openxmlformats.org/officeDocument/2006/relationships">
+  <p:cSld>
+    <p:bg>
+      <p:bgPr>
+        <a:solidFill>
+          <a:srgbClr val="0F172A"/>
+        </a:solidFill>
+      </p:bgPr>
+    </p:bg>
+    <p:spTree>
+      <p:nvGrpSpPr>
+        <p:cNvPr id="1" name=""/>
+        <p:cNvGrpSpPr/>
+        <p:nvPr/>
+      </p:nvGrpSpPr>
+      <p:grpSpPr/>
+      <p:sp>
+        <p:nvSpPr>
+          <p:cNvPr id="2" name="Text 0"/>
+          <p:cNvSpPr txBox="1"/>
+          <p:nvPr/>
+        </p:nvSpPr>
+        <p:spPr>
+          <a:xfrm>
+            <a:off x="548640" y="457200"/>
+            <a:ext cx="10515600" cy="640080"/>
+          </a:xfrm>
+          <a:prstGeom prst="rect">
+            <a:avLst/>
+          </a:prstGeom>
+          <a:noFill/>
+          <a:ln/>
+        </p:spPr>
+        <p:txBody>
+          <a:bodyPr wrap="square" lIns="0" tIns="0" rIns="0" bIns="0" rtlCol="0" anchor="ctr"/>
+          <a:lstStyle/>
+          <a:p>
+            <a:pPr indent="0" marL="0">
+              <a:buNone/>
+            </a:pPr>
+            <a:r>
+              <a:rPr lang="en-US" sz="2800" b="1" dirty="0">
+                <a:solidFill>
+                  <a:srgbClr val="FFFFFF"/>
+                </a:solidFill>
+                <a:latin typeface="Cambria" pitchFamily="34" charset="0"/>
+                <a:ea typeface="Cambria" pitchFamily="34" charset="-122"/>
+                <a:cs typeface="Cambria" pitchFamily="34" charset="-120"/>
+              </a:rPr>
+              <a:t>Extended Scope — Full Arabic &amp; Production Hardening</a:t>
+            </a:r>
+            <a:endParaRPr lang="en-US" sz="2800" dirty="0"/>
+          </a:p>
+        </p:txBody>
+      </p:sp>
+      <p:sp>
+        <p:nvSpPr>
+          <p:cNvPr id="3" name="Text 1"/>
+          <p:cNvSpPr txBox="1"/>
+          <p:nvPr/>
+        </p:nvSpPr>
+        <p:spPr>
+          <a:xfrm>
+            <a:off x="548640" y="1097280"/>
+            <a:ext cx="10515600" cy="365760"/>
+          </a:xfrm>
+          <a:prstGeom prst="rect">
+            <a:avLst/>
+          </a:prstGeom>
+          <a:noFill/>
+          <a:ln/>
+        </p:spPr>
+        <p:txBody>
+          <a:bodyPr wrap="square" lIns="0" tIns="0" rIns="0" bIns="0" rtlCol="0" anchor="ctr"/>
+          <a:lstStyle/>
+          <a:p>
+            <a:pPr indent="0" marL="0">
+              <a:buNone/>
+            </a:pPr>
+            <a:r>
+              <a:rPr lang="en-US" sz="1350" dirty="0">
+                <a:solidFill>
+                  <a:srgbClr val="CADCFC"/>
+                </a:solidFill>
+                <a:latin typeface="Calibri" pitchFamily="34" charset="0"/>
+                <a:ea typeface="Calibri" pitchFamily="34" charset="-122"/>
+                <a:cs typeface="Calibri" pitchFamily="34" charset="-120"/>
+              </a:rPr>
+              <a:t>The final round: every word in Arabic, a stricter security posture and production-ready data handling — 54 more tests, all passing.</a:t>
+            </a:r>
+            <a:endParaRPr lang="en-US" sz="1350" dirty="0"/>
+          </a:p>
+        </p:txBody>
+      </p:sp>
+      <p:sp>
+        <p:nvSpPr>
+          <p:cNvPr id="4" name="Shape 2"/>
+          <p:cNvSpPr/>
+          <p:nvPr/>
+        </p:nvSpPr>
+        <p:spPr>
+          <a:xfrm>
+            <a:off x="548640" y="1691640"/>
+            <a:ext cx="5394960" cy="1051560"/>
+          </a:xfrm>
+          <a:prstGeom prst="roundRect">
+            <a:avLst>
+              <a:gd name="adj" fmla="val 6957"/>
+            </a:avLst>
+          </a:prstGeom>
+          <a:solidFill>
+            <a:srgbClr val="1E293B"/>
+          </a:solidFill>
+          <a:ln/>
+        </p:spPr>
+        <p:txBody>
+          <a:bodyPr/>
+          <a:p/>
+        </p:txBody>
+      </p:sp>
+      <p:sp>
+        <p:nvSpPr>
+          <p:cNvPr id="5" name="Shape 3"/>
+          <p:cNvSpPr/>
+          <p:nvPr/>
+        </p:nvSpPr>
+        <p:spPr>
+          <a:xfrm>
+            <a:off x="713232" y="1856232"/>
+            <a:ext cx="365760" cy="365760"/>
+          </a:xfrm>
+          <a:prstGeom prst="ellipse">
+            <a:avLst/>
+          </a:prstGeom>
+          <a:solidFill>
+            <a:srgbClr val="16A34A"/>
+          </a:solidFill>
+          <a:ln/>
+        </p:spPr>
+        <p:txBody>
+          <a:bodyPr/>
+          <a:p/>
+        </p:txBody>
+      </p:sp>
+      <p:sp>
+        <p:nvSpPr>
+          <p:cNvPr id="6" name="Text 4"/>
+          <p:cNvSpPr txBox="1"/>
+          <p:nvPr/>
+        </p:nvSpPr>
+        <p:spPr>
+          <a:xfrm>
+            <a:off x="713232" y="1856232"/>
+            <a:ext cx="365760" cy="365760"/>
+          </a:xfrm>
+          <a:prstGeom prst="rect">
+            <a:avLst/>
+          </a:prstGeom>
+          <a:noFill/>
+          <a:ln/>
+        </p:spPr>
+        <p:txBody>
+          <a:bodyPr wrap="square" lIns="0" tIns="0" rIns="0" bIns="0" rtlCol="0" anchor="ctr"/>
+          <a:lstStyle/>
+          <a:p>
+            <a:pPr algn="ctr" indent="0" marL="0">
+              <a:buNone/>
+            </a:pPr>
+            <a:r>
+              <a:rPr lang="en-US" sz="1600" b="1" dirty="0">
+                <a:solidFill>
+                  <a:srgbClr val="FFFFFF"/>
+                </a:solidFill>
+                <a:latin typeface="Cambria" pitchFamily="34" charset="0"/>
+                <a:ea typeface="Cambria" pitchFamily="34" charset="-122"/>
+                <a:cs typeface="Cambria" pitchFamily="34" charset="-120"/>
+              </a:rPr>
+              <a:t>✓</a:t>
+            </a:r>
+            <a:endParaRPr lang="en-US" sz="1600" dirty="0"/>
+          </a:p>
+        </p:txBody>
+      </p:sp>
+      <p:sp>
+        <p:nvSpPr>
+          <p:cNvPr id="7" name="Text 5"/>
+          <p:cNvSpPr txBox="1"/>
+          <p:nvPr/>
+        </p:nvSpPr>
+        <p:spPr>
+          <a:xfrm>
+            <a:off x="1234440" y="1783080"/>
+            <a:ext cx="4526280" cy="320040"/>
+          </a:xfrm>
+          <a:prstGeom prst="rect">
+            <a:avLst/>
+          </a:prstGeom>
+          <a:noFill/>
+          <a:ln/>
+        </p:spPr>
+        <p:txBody>
+          <a:bodyPr wrap="square" lIns="0" tIns="0" rIns="0" bIns="0" rtlCol="0" anchor="ctr"/>
+          <a:lstStyle/>
+          <a:p>
+            <a:pPr indent="0" marL="0">
+              <a:buNone/>
+            </a:pPr>
+            <a:r>
+              <a:rPr lang="en-US" sz="1300" b="1" dirty="0">
+                <a:solidFill>
+                  <a:srgbClr val="FFFFFF"/>
+                </a:solidFill>
+                <a:latin typeface="Calibri" pitchFamily="34" charset="0"/>
+                <a:ea typeface="Calibri" pitchFamily="34" charset="-122"/>
+                <a:cs typeface="Calibri" pitchFamily="34" charset="-120"/>
+              </a:rPr>
+              <a:t>Arabic on every screen</a:t>
+            </a:r>
+            <a:endParaRPr lang="en-US" sz="1300" dirty="0"/>
+          </a:p>
+        </p:txBody>
+      </p:sp>
+      <p:sp>
+        <p:nvSpPr>
+          <p:cNvPr id="8" name="Text 6"/>
+          <p:cNvSpPr txBox="1"/>
+          <p:nvPr/>
+        </p:nvSpPr>
+        <p:spPr>
+          <a:xfrm>
+            <a:off x="1234440" y="2112264"/>
+            <a:ext cx="4526280" cy="548640"/>
+          </a:xfrm>
+          <a:prstGeom prst="rect">
+            <a:avLst/>
+          </a:prstGeom>
+          <a:noFill/>
+          <a:ln/>
+        </p:spPr>
+        <p:txBody>
+          <a:bodyPr wrap="square" lIns="0" tIns="0" rIns="0" bIns="0" rtlCol="0" anchor="ctr"/>
+          <a:lstStyle/>
+          <a:p>
+            <a:pPr indent="0" marL="0">
+              <a:buNone/>
+            </a:pPr>
+            <a:r>
+              <a:rPr lang="en-US" sz="1000" dirty="0">
+                <a:solidFill>
+                  <a:srgbClr val="CADCFC"/>
+                </a:solidFill>
+                <a:latin typeface="Calibri" pitchFamily="34" charset="0"/>
+                <a:ea typeface="Calibri" pitchFamily="34" charset="-122"/>
+                <a:cs typeface="Calibri" pitchFamily="34" charset="-120"/>
+              </a:rPr>
+              <a:t>Every page, form option and message — over 600 phrases; a test fails if one is missing</a:t>
+            </a:r>
+            <a:endParaRPr lang="en-US" sz="1000" dirty="0"/>
+          </a:p>
+        </p:txBody>
+      </p:sp>
+      <p:sp>
+        <p:nvSpPr>
+          <p:cNvPr id="9" name="Shape 7"/>
+          <p:cNvSpPr/>
+          <p:nvPr/>
+        </p:nvSpPr>
+        <p:spPr>
+          <a:xfrm>
+            <a:off x="6217920" y="1691640"/>
+            <a:ext cx="5394960" cy="1051560"/>
+          </a:xfrm>
+          <a:prstGeom prst="roundRect">
+            <a:avLst>
+              <a:gd name="adj" fmla="val 6957"/>
+            </a:avLst>
+          </a:prstGeom>
+          <a:solidFill>
+            <a:srgbClr val="1E293B"/>
+          </a:solidFill>
+          <a:ln/>
+        </p:spPr>
+        <p:txBody>
+          <a:bodyPr/>
+          <a:p/>
+        </p:txBody>
+      </p:sp>
+      <p:sp>
+        <p:nvSpPr>
+          <p:cNvPr id="10" name="Shape 8"/>
+          <p:cNvSpPr/>
+          <p:nvPr/>
+        </p:nvSpPr>
+        <p:spPr>
+          <a:xfrm>
+            <a:off x="6382512" y="1856232"/>
+            <a:ext cx="365760" cy="365760"/>
+          </a:xfrm>
+          <a:prstGeom prst="ellipse">
+            <a:avLst/>
+          </a:prstGeom>
+          <a:solidFill>
+            <a:srgbClr val="16A34A"/>
+          </a:solidFill>
+          <a:ln/>
+        </p:spPr>
+        <p:txBody>
+          <a:bodyPr/>
+          <a:p/>
+        </p:txBody>
+      </p:sp>
+      <p:sp>
+        <p:nvSpPr>
+          <p:cNvPr id="11" name="Text 9"/>
+          <p:cNvSpPr txBox="1"/>
+          <p:nvPr/>
+        </p:nvSpPr>
+        <p:spPr>
+          <a:xfrm>
+            <a:off x="6382512" y="1856232"/>
+            <a:ext cx="365760" cy="365760"/>
+          </a:xfrm>
+          <a:prstGeom prst="rect">
+            <a:avLst/>
+          </a:prstGeom>
+          <a:noFill/>
+          <a:ln/>
+        </p:spPr>
+        <p:txBody>
+          <a:bodyPr wrap="square" lIns="0" tIns="0" rIns="0" bIns="0" rtlCol="0" anchor="ctr"/>
+          <a:lstStyle/>
+          <a:p>
+            <a:pPr algn="ctr" indent="0" marL="0">
+              <a:buNone/>
+            </a:pPr>
+            <a:r>
+              <a:rPr lang="en-US" sz="1600" b="1" dirty="0">
+                <a:solidFill>
+                  <a:srgbClr val="FFFFFF"/>
+                </a:solidFill>
+                <a:latin typeface="Cambria" pitchFamily="34" charset="0"/>
+                <a:ea typeface="Cambria" pitchFamily="34" charset="-122"/>
+                <a:cs typeface="Cambria" pitchFamily="34" charset="-120"/>
+              </a:rPr>
+              <a:t>✓</a:t>
+            </a:r>
+            <a:endParaRPr lang="en-US" sz="1600" dirty="0"/>
+          </a:p>
+        </p:txBody>
+      </p:sp>
+      <p:sp>
+        <p:nvSpPr>
+          <p:cNvPr id="12" name="Text 10"/>
+          <p:cNvSpPr txBox="1"/>
+          <p:nvPr/>
+        </p:nvSpPr>
+        <p:spPr>
+          <a:xfrm>
+            <a:off x="6903720" y="1783080"/>
+            <a:ext cx="4526280" cy="320040"/>
+          </a:xfrm>
+          <a:prstGeom prst="rect">
+            <a:avLst/>
+          </a:prstGeom>
+          <a:noFill/>
+          <a:ln/>
+        </p:spPr>
+        <p:txBody>
+          <a:bodyPr wrap="square" lIns="0" tIns="0" rIns="0" bIns="0" rtlCol="0" anchor="ctr"/>
+          <a:lstStyle/>
+          <a:p>
+            <a:pPr indent="0" marL="0">
+              <a:buNone/>
+            </a:pPr>
+            <a:r>
+              <a:rPr lang="en-US" sz="1300" b="1" dirty="0">
+                <a:solidFill>
+                  <a:srgbClr val="FFFFFF"/>
+                </a:solidFill>
+                <a:latin typeface="Calibri" pitchFamily="34" charset="0"/>
+                <a:ea typeface="Calibri" pitchFamily="34" charset="-122"/>
+                <a:cs typeface="Calibri" pitchFamily="34" charset="-120"/>
+              </a:rPr>
+              <a:t>Emails &amp; SMS in each user’s language</a:t>
+            </a:r>
+            <a:endParaRPr lang="en-US" sz="1300" dirty="0"/>
+          </a:p>
+        </p:txBody>
+      </p:sp>
+      <p:sp>
+        <p:nvSpPr>
+          <p:cNvPr id="13" name="Text 11"/>
+          <p:cNvSpPr txBox="1"/>
+          <p:nvPr/>
+        </p:nvSpPr>
+        <p:spPr>
+          <a:xfrm>
+            <a:off x="6903720" y="2112264"/>
+            <a:ext cx="4526280" cy="548640"/>
+          </a:xfrm>
+          <a:prstGeom prst="rect">
+            <a:avLst/>
+          </a:prstGeom>
+          <a:noFill/>
+          <a:ln/>
+        </p:spPr>
+        <p:txBody>
+          <a:bodyPr wrap="square" lIns="0" tIns="0" rIns="0" bIns="0" rtlCol="0" anchor="ctr"/>
+          <a:lstStyle/>
+          <a:p>
+            <a:pPr indent="0" marL="0">
+              <a:buNone/>
+            </a:pPr>
+            <a:r>
+              <a:rPr lang="en-US" sz="1000" dirty="0">
+                <a:solidFill>
+                  <a:srgbClr val="CADCFC"/>
+                </a:solidFill>
+                <a:latin typeface="Calibri" pitchFamily="34" charset="0"/>
+                <a:ea typeface="Calibri" pitchFamily="34" charset="-122"/>
+                <a:cs typeface="Calibri" pitchFamily="34" charset="-120"/>
+              </a:rPr>
+              <a:t>Sent in the language the user last chose, including by the nightly jobs</a:t>
+            </a:r>
+            <a:endParaRPr lang="en-US" sz="1000" dirty="0"/>
+          </a:p>
+        </p:txBody>
+      </p:sp>
+      <p:sp>
+        <p:nvSpPr>
+          <p:cNvPr id="14" name="Shape 12"/>
+          <p:cNvSpPr/>
+          <p:nvPr/>
+        </p:nvSpPr>
+        <p:spPr>
+          <a:xfrm>
+            <a:off x="548640" y="2907792"/>
+            <a:ext cx="5394960" cy="1051560"/>
+          </a:xfrm>
+          <a:prstGeom prst="roundRect">
+            <a:avLst>
+              <a:gd name="adj" fmla="val 6957"/>
+            </a:avLst>
+          </a:prstGeom>
+          <a:solidFill>
+            <a:srgbClr val="1E293B"/>
+          </a:solidFill>
+          <a:ln/>
+        </p:spPr>
+        <p:txBody>
+          <a:bodyPr/>
+          <a:p/>
+        </p:txBody>
+      </p:sp>
+      <p:sp>
+        <p:nvSpPr>
+          <p:cNvPr id="15" name="Shape 13"/>
+          <p:cNvSpPr/>
+          <p:nvPr/>
+        </p:nvSpPr>
+        <p:spPr>
+          <a:xfrm>
+            <a:off x="713232" y="3072384"/>
+            <a:ext cx="365760" cy="365760"/>
+          </a:xfrm>
+          <a:prstGeom prst="ellipse">
+            <a:avLst/>
+          </a:prstGeom>
+          <a:solidFill>
+            <a:srgbClr val="16A34A"/>
+          </a:solidFill>
+          <a:ln/>
+        </p:spPr>
+        <p:txBody>
+          <a:bodyPr/>
+          <a:p/>
+        </p:txBody>
+      </p:sp>
+      <p:sp>
+        <p:nvSpPr>
+          <p:cNvPr id="16" name="Text 14"/>
+          <p:cNvSpPr txBox="1"/>
+          <p:nvPr/>
+        </p:nvSpPr>
+        <p:spPr>
+          <a:xfrm>
+            <a:off x="713232" y="3072384"/>
+            <a:ext cx="365760" cy="365760"/>
+          </a:xfrm>
+          <a:prstGeom prst="rect">
+            <a:avLst/>
+          </a:prstGeom>
+          <a:noFill/>
+          <a:ln/>
+        </p:spPr>
+        <p:txBody>
+          <a:bodyPr wrap="square" lIns="0" tIns="0" rIns="0" bIns="0" rtlCol="0" anchor="ctr"/>
+          <a:lstStyle/>
+          <a:p>
+            <a:pPr algn="ctr" indent="0" marL="0">
+              <a:buNone/>
+            </a:pPr>
+            <a:r>
+              <a:rPr lang="en-US" sz="1600" b="1" dirty="0">
+                <a:solidFill>
+                  <a:srgbClr val="FFFFFF"/>
+                </a:solidFill>
+                <a:latin typeface="Cambria" pitchFamily="34" charset="0"/>
+                <a:ea typeface="Cambria" pitchFamily="34" charset="-122"/>
+                <a:cs typeface="Cambria" pitchFamily="34" charset="-120"/>
+              </a:rPr>
+              <a:t>✓</a:t>
+            </a:r>
+            <a:endParaRPr lang="en-US" sz="1600" dirty="0"/>
+          </a:p>
+        </p:txBody>
+      </p:sp>
+      <p:sp>
+        <p:nvSpPr>
+          <p:cNvPr id="17" name="Text 15"/>
+          <p:cNvSpPr txBox="1"/>
+          <p:nvPr/>
+        </p:nvSpPr>
+        <p:spPr>
+          <a:xfrm>
+            <a:off x="1234440" y="2999232"/>
+            <a:ext cx="4526280" cy="320040"/>
+          </a:xfrm>
+          <a:prstGeom prst="rect">
+            <a:avLst/>
+          </a:prstGeom>
+          <a:noFill/>
+          <a:ln/>
+        </p:spPr>
+        <p:txBody>
+          <a:bodyPr wrap="square" lIns="0" tIns="0" rIns="0" bIns="0" rtlCol="0" anchor="ctr"/>
+          <a:lstStyle/>
+          <a:p>
+            <a:pPr indent="0" marL="0">
+              <a:buNone/>
+            </a:pPr>
+            <a:r>
+              <a:rPr lang="en-US" sz="1300" b="1" dirty="0">
+                <a:solidFill>
+                  <a:srgbClr val="FFFFFF"/>
+                </a:solidFill>
+                <a:latin typeface="Calibri" pitchFamily="34" charset="0"/>
+                <a:ea typeface="Calibri" pitchFamily="34" charset="-122"/>
+                <a:cs typeface="Calibri" pitchFamily="34" charset="-120"/>
+              </a:rPr>
+              <a:t>Arabic PDFs &amp; spreadsheets</a:t>
+            </a:r>
+            <a:endParaRPr lang="en-US" sz="1300" dirty="0"/>
+          </a:p>
+        </p:txBody>
+      </p:sp>
+      <p:sp>
+        <p:nvSpPr>
+          <p:cNvPr id="18" name="Text 16"/>
+          <p:cNvSpPr txBox="1"/>
+          <p:nvPr/>
+        </p:nvSpPr>
+        <p:spPr>
+          <a:xfrm>
+            <a:off x="1234440" y="3328416"/>
+            <a:ext cx="4526280" cy="548640"/>
+          </a:xfrm>
+          <a:prstGeom prst="rect">
+            <a:avLst/>
+          </a:prstGeom>
+          <a:noFill/>
+          <a:ln/>
+        </p:spPr>
+        <p:txBody>
+          <a:bodyPr wrap="square" lIns="0" tIns="0" rIns="0" bIns="0" rtlCol="0" anchor="ctr"/>
+          <a:lstStyle/>
+          <a:p>
+            <a:pPr indent="0" marL="0">
+              <a:buNone/>
+            </a:pPr>
+            <a:r>
+              <a:rPr lang="en-US" sz="1000" dirty="0">
+                <a:solidFill>
+                  <a:srgbClr val="CADCFC"/>
+                </a:solidFill>
+                <a:latin typeface="Calibri" pitchFamily="34" charset="0"/>
+                <a:ea typeface="Calibri" pitchFamily="34" charset="-122"/>
+                <a:cs typeface="Calibri" pitchFamily="34" charset="-120"/>
+              </a:rPr>
+              <a:t>PDF letters joined and right to left, tables mirrored; Excel sheets open right to left</a:t>
+            </a:r>
+            <a:endParaRPr lang="en-US" sz="1000" dirty="0"/>
+          </a:p>
+        </p:txBody>
+      </p:sp>
+      <p:sp>
+        <p:nvSpPr>
+          <p:cNvPr id="19" name="Shape 17"/>
+          <p:cNvSpPr/>
+          <p:nvPr/>
+        </p:nvSpPr>
+        <p:spPr>
+          <a:xfrm>
+            <a:off x="6217920" y="2907792"/>
+            <a:ext cx="5394960" cy="1051560"/>
+          </a:xfrm>
+          <a:prstGeom prst="roundRect">
+            <a:avLst>
+              <a:gd name="adj" fmla="val 6957"/>
+            </a:avLst>
+          </a:prstGeom>
+          <a:solidFill>
+            <a:srgbClr val="1E293B"/>
+          </a:solidFill>
+          <a:ln/>
+        </p:spPr>
+        <p:txBody>
+          <a:bodyPr/>
+          <a:p/>
+        </p:txBody>
+      </p:sp>
+      <p:sp>
+        <p:nvSpPr>
+          <p:cNvPr id="20" name="Shape 18"/>
+          <p:cNvSpPr/>
+          <p:nvPr/>
+        </p:nvSpPr>
+        <p:spPr>
+          <a:xfrm>
+            <a:off x="6382512" y="3072384"/>
+            <a:ext cx="365760" cy="365760"/>
+          </a:xfrm>
+          <a:prstGeom prst="ellipse">
+            <a:avLst/>
+          </a:prstGeom>
+          <a:solidFill>
+            <a:srgbClr val="16A34A"/>
+          </a:solidFill>
+          <a:ln/>
+        </p:spPr>
+        <p:txBody>
+          <a:bodyPr/>
+          <a:p/>
+        </p:txBody>
+      </p:sp>
+      <p:sp>
+        <p:nvSpPr>
+          <p:cNvPr id="21" name="Text 19"/>
+          <p:cNvSpPr txBox="1"/>
+          <p:nvPr/>
+        </p:nvSpPr>
+        <p:spPr>
+          <a:xfrm>
+            <a:off x="6382512" y="3072384"/>
+            <a:ext cx="365760" cy="365760"/>
+          </a:xfrm>
+          <a:prstGeom prst="rect">
+            <a:avLst/>
+          </a:prstGeom>
+          <a:noFill/>
+          <a:ln/>
+        </p:spPr>
+        <p:txBody>
+          <a:bodyPr wrap="square" lIns="0" tIns="0" rIns="0" bIns="0" rtlCol="0" anchor="ctr"/>
+          <a:lstStyle/>
+          <a:p>
+            <a:pPr algn="ctr" indent="0" marL="0">
+              <a:buNone/>
+            </a:pPr>
+            <a:r>
+              <a:rPr lang="en-US" sz="1600" b="1" dirty="0">
+                <a:solidFill>
+                  <a:srgbClr val="FFFFFF"/>
+                </a:solidFill>
+                <a:latin typeface="Cambria" pitchFamily="34" charset="0"/>
+                <a:ea typeface="Cambria" pitchFamily="34" charset="-122"/>
+                <a:cs typeface="Cambria" pitchFamily="34" charset="-120"/>
+              </a:rPr>
+              <a:t>✓</a:t>
+            </a:r>
+            <a:endParaRPr lang="en-US" sz="1600" dirty="0"/>
+          </a:p>
+        </p:txBody>
+      </p:sp>
+      <p:sp>
+        <p:nvSpPr>
+          <p:cNvPr id="22" name="Text 20"/>
+          <p:cNvSpPr txBox="1"/>
+          <p:nvPr/>
+        </p:nvSpPr>
+        <p:spPr>
+          <a:xfrm>
+            <a:off x="6903720" y="2999232"/>
+            <a:ext cx="4526280" cy="320040"/>
+          </a:xfrm>
+          <a:prstGeom prst="rect">
+            <a:avLst/>
+          </a:prstGeom>
+          <a:noFill/>
+          <a:ln/>
+        </p:spPr>
+        <p:txBody>
+          <a:bodyPr wrap="square" lIns="0" tIns="0" rIns="0" bIns="0" rtlCol="0" anchor="ctr"/>
+          <a:lstStyle/>
+          <a:p>
+            <a:pPr indent="0" marL="0">
+              <a:buNone/>
+            </a:pPr>
+            <a:r>
+              <a:rPr lang="en-US" sz="1300" b="1" dirty="0">
+                <a:solidFill>
+                  <a:srgbClr val="FFFFFF"/>
+                </a:solidFill>
+                <a:latin typeface="Calibri" pitchFamily="34" charset="0"/>
+                <a:ea typeface="Calibri" pitchFamily="34" charset="-122"/>
+                <a:cs typeface="Calibri" pitchFamily="34" charset="-120"/>
+              </a:rPr>
+              <a:t>Currency everywhere</a:t>
+            </a:r>
+            <a:endParaRPr lang="en-US" sz="1300" dirty="0"/>
+          </a:p>
+        </p:txBody>
+      </p:sp>
+      <p:sp>
+        <p:nvSpPr>
+          <p:cNvPr id="23" name="Text 21"/>
+          <p:cNvSpPr txBox="1"/>
+          <p:nvPr/>
+        </p:nvSpPr>
+        <p:spPr>
+          <a:xfrm>
+            <a:off x="6903720" y="3328416"/>
+            <a:ext cx="4526280" cy="548640"/>
+          </a:xfrm>
+          <a:prstGeom prst="rect">
+            <a:avLst/>
+          </a:prstGeom>
+          <a:noFill/>
+          <a:ln/>
+        </p:spPr>
+        <p:txBody>
+          <a:bodyPr wrap="square" lIns="0" tIns="0" rIns="0" bIns="0" rtlCol="0" anchor="ctr"/>
+          <a:lstStyle/>
+          <a:p>
+            <a:pPr indent="0" marL="0">
+              <a:buNone/>
+            </a:pPr>
+            <a:r>
+              <a:rPr lang="en-US" sz="1000" dirty="0">
+                <a:solidFill>
+                  <a:srgbClr val="CADCFC"/>
+                </a:solidFill>
+                <a:latin typeface="Calibri" pitchFamily="34" charset="0"/>
+                <a:ea typeface="Calibri" pitchFamily="34" charset="-122"/>
+                <a:cs typeface="Calibri" pitchFamily="34" charset="-120"/>
+              </a:rPr>
+              <a:t>Every amount shown as “USD 1,250.00” — screens, messages, emails and PDFs</a:t>
+            </a:r>
+            <a:endParaRPr lang="en-US" sz="1000" dirty="0"/>
+          </a:p>
+        </p:txBody>
+      </p:sp>
+      <p:sp>
+        <p:nvSpPr>
+          <p:cNvPr id="24" name="Shape 22"/>
+          <p:cNvSpPr/>
+          <p:nvPr/>
+        </p:nvSpPr>
+        <p:spPr>
+          <a:xfrm>
+            <a:off x="548640" y="4123944"/>
+            <a:ext cx="5394960" cy="1051560"/>
+          </a:xfrm>
+          <a:prstGeom prst="roundRect">
+            <a:avLst>
+              <a:gd name="adj" fmla="val 6957"/>
+            </a:avLst>
+          </a:prstGeom>
+          <a:solidFill>
+            <a:srgbClr val="1E293B"/>
+          </a:solidFill>
+          <a:ln/>
+        </p:spPr>
+        <p:txBody>
+          <a:bodyPr/>
+          <a:p/>
+        </p:txBody>
+      </p:sp>
+      <p:sp>
+        <p:nvSpPr>
+          <p:cNvPr id="25" name="Shape 23"/>
+          <p:cNvSpPr/>
+          <p:nvPr/>
+        </p:nvSpPr>
+        <p:spPr>
+          <a:xfrm>
+            <a:off x="713232" y="4288536"/>
+            <a:ext cx="365760" cy="365760"/>
+          </a:xfrm>
+          <a:prstGeom prst="ellipse">
+            <a:avLst/>
+          </a:prstGeom>
+          <a:solidFill>
+            <a:srgbClr val="16A34A"/>
+          </a:solidFill>
+          <a:ln/>
+        </p:spPr>
+        <p:txBody>
+          <a:bodyPr/>
+          <a:p/>
+        </p:txBody>
+      </p:sp>
+      <p:sp>
+        <p:nvSpPr>
+          <p:cNvPr id="26" name="Text 24"/>
+          <p:cNvSpPr txBox="1"/>
+          <p:nvPr/>
+        </p:nvSpPr>
+        <p:spPr>
+          <a:xfrm>
+            <a:off x="713232" y="4288536"/>
+            <a:ext cx="365760" cy="365760"/>
+          </a:xfrm>
+          <a:prstGeom prst="rect">
+            <a:avLst/>
+          </a:prstGeom>
+          <a:noFill/>
+          <a:ln/>
+        </p:spPr>
+        <p:txBody>
+          <a:bodyPr wrap="square" lIns="0" tIns="0" rIns="0" bIns="0" rtlCol="0" anchor="ctr"/>
+          <a:lstStyle/>
+          <a:p>
+            <a:pPr algn="ctr" indent="0" marL="0">
+              <a:buNone/>
+            </a:pPr>
+            <a:r>
+              <a:rPr lang="en-US" sz="1600" b="1" dirty="0">
+                <a:solidFill>
+                  <a:srgbClr val="FFFFFF"/>
+                </a:solidFill>
+                <a:latin typeface="Cambria" pitchFamily="34" charset="0"/>
+                <a:ea typeface="Cambria" pitchFamily="34" charset="-122"/>
+                <a:cs typeface="Cambria" pitchFamily="34" charset="-120"/>
+              </a:rPr>
+              <a:t>✓</a:t>
+            </a:r>
+            <a:endParaRPr lang="en-US" sz="1600" dirty="0"/>
+          </a:p>
+        </p:txBody>
+      </p:sp>
+      <p:sp>
+        <p:nvSpPr>
+          <p:cNvPr id="27" name="Text 25"/>
+          <p:cNvSpPr txBox="1"/>
+          <p:nvPr/>
+        </p:nvSpPr>
+        <p:spPr>
+          <a:xfrm>
+            <a:off x="1234440" y="4215384"/>
+            <a:ext cx="4526280" cy="320040"/>
+          </a:xfrm>
+          <a:prstGeom prst="rect">
+            <a:avLst/>
+          </a:prstGeom>
+          <a:noFill/>
+          <a:ln/>
+        </p:spPr>
+        <p:txBody>
+          <a:bodyPr wrap="square" lIns="0" tIns="0" rIns="0" bIns="0" rtlCol="0" anchor="ctr"/>
+          <a:lstStyle/>
+          <a:p>
+            <a:pPr indent="0" marL="0">
+              <a:buNone/>
+            </a:pPr>
+            <a:r>
+              <a:rPr lang="en-US" sz="1300" b="1" dirty="0">
+                <a:solidFill>
+                  <a:srgbClr val="FFFFFF"/>
+                </a:solidFill>
+                <a:latin typeface="Calibri" pitchFamily="34" charset="0"/>
+                <a:ea typeface="Calibri" pitchFamily="34" charset="-122"/>
+                <a:cs typeface="Calibri" pitchFamily="34" charset="-120"/>
+              </a:rPr>
+              <a:t>Security headers &amp; cookies</a:t>
+            </a:r>
+            <a:endParaRPr lang="en-US" sz="1300" dirty="0"/>
+          </a:p>
+        </p:txBody>
+      </p:sp>
+      <p:sp>
+        <p:nvSpPr>
+          <p:cNvPr id="28" name="Text 26"/>
+          <p:cNvSpPr txBox="1"/>
+          <p:nvPr/>
+        </p:nvSpPr>
+        <p:spPr>
+          <a:xfrm>
+            <a:off x="1234440" y="4544568"/>
+            <a:ext cx="4526280" cy="548640"/>
+          </a:xfrm>
+          <a:prstGeom prst="rect">
+            <a:avLst/>
+          </a:prstGeom>
+          <a:noFill/>
+          <a:ln/>
+        </p:spPr>
+        <p:txBody>
+          <a:bodyPr wrap="square" lIns="0" tIns="0" rIns="0" bIns="0" rtlCol="0" anchor="ctr"/>
+          <a:lstStyle/>
+          <a:p>
+            <a:pPr indent="0" marL="0">
+              <a:buNone/>
+            </a:pPr>
+            <a:r>
+              <a:rPr lang="en-US" sz="1000" dirty="0">
+                <a:solidFill>
+                  <a:srgbClr val="CADCFC"/>
+                </a:solidFill>
+                <a:latin typeface="Calibri" pitchFamily="34" charset="0"/>
+                <a:ea typeface="Calibri" pitchFamily="34" charset="-122"/>
+                <a:cs typeface="Calibri" pitchFamily="34" charset="-120"/>
+              </a:rPr>
+              <a:t>Strict Content-Security-Policy with no inline code, no framing, HSTS, HttpOnly cookies</a:t>
+            </a:r>
+            <a:endParaRPr lang="en-US" sz="1000" dirty="0"/>
+          </a:p>
+        </p:txBody>
+      </p:sp>
+      <p:sp>
+        <p:nvSpPr>
+          <p:cNvPr id="29" name="Shape 27"/>
+          <p:cNvSpPr/>
+          <p:nvPr/>
+        </p:nvSpPr>
+        <p:spPr>
+          <a:xfrm>
+            <a:off x="6217920" y="4123944"/>
+            <a:ext cx="5394960" cy="1051560"/>
+          </a:xfrm>
+          <a:prstGeom prst="roundRect">
+            <a:avLst>
+              <a:gd name="adj" fmla="val 6957"/>
+            </a:avLst>
+          </a:prstGeom>
+          <a:solidFill>
+            <a:srgbClr val="1E293B"/>
+          </a:solidFill>
+          <a:ln/>
+        </p:spPr>
+        <p:txBody>
+          <a:bodyPr/>
+          <a:p/>
+        </p:txBody>
+      </p:sp>
+      <p:sp>
+        <p:nvSpPr>
+          <p:cNvPr id="30" name="Shape 28"/>
+          <p:cNvSpPr/>
+          <p:nvPr/>
+        </p:nvSpPr>
+        <p:spPr>
+          <a:xfrm>
+            <a:off x="6382512" y="4288536"/>
+            <a:ext cx="365760" cy="365760"/>
+          </a:xfrm>
+          <a:prstGeom prst="ellipse">
+            <a:avLst/>
+          </a:prstGeom>
+          <a:solidFill>
+            <a:srgbClr val="16A34A"/>
+          </a:solidFill>
+          <a:ln/>
+        </p:spPr>
+        <p:txBody>
+          <a:bodyPr/>
+          <a:p/>
+        </p:txBody>
+      </p:sp>
+      <p:sp>
+        <p:nvSpPr>
+          <p:cNvPr id="31" name="Text 29"/>
+          <p:cNvSpPr txBox="1"/>
+          <p:nvPr/>
+        </p:nvSpPr>
+        <p:spPr>
+          <a:xfrm>
+            <a:off x="6382512" y="4288536"/>
+            <a:ext cx="365760" cy="365760"/>
+          </a:xfrm>
+          <a:prstGeom prst="rect">
+            <a:avLst/>
+          </a:prstGeom>
+          <a:noFill/>
+          <a:ln/>
+        </p:spPr>
+        <p:txBody>
+          <a:bodyPr wrap="square" lIns="0" tIns="0" rIns="0" bIns="0" rtlCol="0" anchor="ctr"/>
+          <a:lstStyle/>
+          <a:p>
+            <a:pPr algn="ctr" indent="0" marL="0">
+              <a:buNone/>
+            </a:pPr>
+            <a:r>
+              <a:rPr lang="en-US" sz="1600" b="1" dirty="0">
+                <a:solidFill>
+                  <a:srgbClr val="FFFFFF"/>
+                </a:solidFill>
+                <a:latin typeface="Cambria" pitchFamily="34" charset="0"/>
+                <a:ea typeface="Cambria" pitchFamily="34" charset="-122"/>
+                <a:cs typeface="Cambria" pitchFamily="34" charset="-120"/>
+              </a:rPr>
+              <a:t>✓</a:t>
+            </a:r>
+            <a:endParaRPr lang="en-US" sz="1600" dirty="0"/>
+          </a:p>
+        </p:txBody>
+      </p:sp>
+      <p:sp>
+        <p:nvSpPr>
+          <p:cNvPr id="32" name="Text 30"/>
+          <p:cNvSpPr txBox="1"/>
+          <p:nvPr/>
+        </p:nvSpPr>
+        <p:spPr>
+          <a:xfrm>
+            <a:off x="6903720" y="4215384"/>
+            <a:ext cx="4526280" cy="320040"/>
+          </a:xfrm>
+          <a:prstGeom prst="rect">
+            <a:avLst/>
+          </a:prstGeom>
+          <a:noFill/>
+          <a:ln/>
+        </p:spPr>
+        <p:txBody>
+          <a:bodyPr wrap="square" lIns="0" tIns="0" rIns="0" bIns="0" rtlCol="0" anchor="ctr"/>
+          <a:lstStyle/>
+          <a:p>
+            <a:pPr indent="0" marL="0">
+              <a:buNone/>
+            </a:pPr>
+            <a:r>
+              <a:rPr lang="en-US" sz="1300" b="1" dirty="0">
+                <a:solidFill>
+                  <a:srgbClr val="FFFFFF"/>
+                </a:solidFill>
+                <a:latin typeface="Calibri" pitchFamily="34" charset="0"/>
+                <a:ea typeface="Calibri" pitchFamily="34" charset="-122"/>
+                <a:cs typeface="Calibri" pitchFamily="34" charset="-120"/>
+              </a:rPr>
+              <a:t>No default secret key</a:t>
+            </a:r>
+            <a:endParaRPr lang="en-US" sz="1300" dirty="0"/>
+          </a:p>
+        </p:txBody>
+      </p:sp>
+      <p:sp>
+        <p:nvSpPr>
+          <p:cNvPr id="33" name="Text 31"/>
+          <p:cNvSpPr txBox="1"/>
+          <p:nvPr/>
+        </p:nvSpPr>
+        <p:spPr>
+          <a:xfrm>
+            <a:off x="6903720" y="4544568"/>
+            <a:ext cx="4526280" cy="548640"/>
+          </a:xfrm>
+          <a:prstGeom prst="rect">
+            <a:avLst/>
+          </a:prstGeom>
+          <a:noFill/>
+          <a:ln/>
+        </p:spPr>
+        <p:txBody>
+          <a:bodyPr wrap="square" lIns="0" tIns="0" rIns="0" bIns="0" rtlCol="0" anchor="ctr"/>
+          <a:lstStyle/>
+          <a:p>
+            <a:pPr indent="0" marL="0">
+              <a:buNone/>
+            </a:pPr>
+            <a:r>
+              <a:rPr lang="en-US" sz="1000" dirty="0">
+                <a:solidFill>
+                  <a:srgbClr val="CADCFC"/>
+                </a:solidFill>
+                <a:latin typeface="Calibri" pitchFamily="34" charset="0"/>
+                <a:ea typeface="Calibri" pitchFamily="34" charset="-122"/>
+                <a:cs typeface="Calibri" pitchFamily="34" charset="-120"/>
+              </a:rPr>
+              <a:t>The app refuses to start with a missing or published SECRET_KEY</a:t>
+            </a:r>
+            <a:endParaRPr lang="en-US" sz="1000" dirty="0"/>
+          </a:p>
+        </p:txBody>
+      </p:sp>
+      <p:sp>
+        <p:nvSpPr>
+          <p:cNvPr id="34" name="Shape 32"/>
+          <p:cNvSpPr/>
+          <p:nvPr/>
+        </p:nvSpPr>
+        <p:spPr>
+          <a:xfrm>
+            <a:off x="548640" y="5340096"/>
+            <a:ext cx="5394960" cy="1051560"/>
+          </a:xfrm>
+          <a:prstGeom prst="roundRect">
+            <a:avLst>
+              <a:gd name="adj" fmla="val 6957"/>
+            </a:avLst>
+          </a:prstGeom>
+          <a:solidFill>
+            <a:srgbClr val="1E293B"/>
+          </a:solidFill>
+          <a:ln/>
+        </p:spPr>
+        <p:txBody>
+          <a:bodyPr/>
+          <a:p/>
+        </p:txBody>
+      </p:sp>
+      <p:sp>
+        <p:nvSpPr>
+          <p:cNvPr id="35" name="Shape 33"/>
+          <p:cNvSpPr/>
+          <p:nvPr/>
+        </p:nvSpPr>
+        <p:spPr>
+          <a:xfrm>
+            <a:off x="713232" y="5504688"/>
+            <a:ext cx="365760" cy="365760"/>
+          </a:xfrm>
+          <a:prstGeom prst="ellipse">
+            <a:avLst/>
+          </a:prstGeom>
+          <a:solidFill>
+            <a:srgbClr val="16A34A"/>
+          </a:solidFill>
+          <a:ln/>
+        </p:spPr>
+        <p:txBody>
+          <a:bodyPr/>
+          <a:p/>
+        </p:txBody>
+      </p:sp>
+      <p:sp>
+        <p:nvSpPr>
+          <p:cNvPr id="36" name="Text 34"/>
+          <p:cNvSpPr txBox="1"/>
+          <p:nvPr/>
+        </p:nvSpPr>
+        <p:spPr>
+          <a:xfrm>
+            <a:off x="713232" y="5504688"/>
+            <a:ext cx="365760" cy="365760"/>
+          </a:xfrm>
+          <a:prstGeom prst="rect">
+            <a:avLst/>
+          </a:prstGeom>
+          <a:noFill/>
+          <a:ln/>
+        </p:spPr>
+        <p:txBody>
+          <a:bodyPr wrap="square" lIns="0" tIns="0" rIns="0" bIns="0" rtlCol="0" anchor="ctr"/>
+          <a:lstStyle/>
+          <a:p>
+            <a:pPr algn="ctr" indent="0" marL="0">
+              <a:buNone/>
+            </a:pPr>
+            <a:r>
+              <a:rPr lang="en-US" sz="1600" b="1" dirty="0">
+                <a:solidFill>
+                  <a:srgbClr val="FFFFFF"/>
+                </a:solidFill>
+                <a:latin typeface="Cambria" pitchFamily="34" charset="0"/>
+                <a:ea typeface="Cambria" pitchFamily="34" charset="-122"/>
+                <a:cs typeface="Cambria" pitchFamily="34" charset="-120"/>
+              </a:rPr>
+              <a:t>✓</a:t>
+            </a:r>
+            <a:endParaRPr lang="en-US" sz="1600" dirty="0"/>
+          </a:p>
+        </p:txBody>
+      </p:sp>
+      <p:sp>
+        <p:nvSpPr>
+          <p:cNvPr id="37" name="Text 35"/>
+          <p:cNvSpPr txBox="1"/>
+          <p:nvPr/>
+        </p:nvSpPr>
+        <p:spPr>
+          <a:xfrm>
+            <a:off x="1234440" y="5431536"/>
+            <a:ext cx="4526280" cy="320040"/>
+          </a:xfrm>
+          <a:prstGeom prst="rect">
+            <a:avLst/>
+          </a:prstGeom>
+          <a:noFill/>
+          <a:ln/>
+        </p:spPr>
+        <p:txBody>
+          <a:bodyPr wrap="square" lIns="0" tIns="0" rIns="0" bIns="0" rtlCol="0" anchor="ctr"/>
+          <a:lstStyle/>
+          <a:p>
+            <a:pPr indent="0" marL="0">
+              <a:buNone/>
+            </a:pPr>
+            <a:r>
+              <a:rPr lang="en-US" sz="1300" b="1" dirty="0">
+                <a:solidFill>
+                  <a:srgbClr val="FFFFFF"/>
+                </a:solidFill>
+                <a:latin typeface="Calibri" pitchFamily="34" charset="0"/>
+                <a:ea typeface="Calibri" pitchFamily="34" charset="-122"/>
+                <a:cs typeface="Calibri" pitchFamily="34" charset="-120"/>
+              </a:rPr>
+              <a:t>Database migrations</a:t>
+            </a:r>
+            <a:endParaRPr lang="en-US" sz="1300" dirty="0"/>
+          </a:p>
+        </p:txBody>
+      </p:sp>
+      <p:sp>
+        <p:nvSpPr>
+          <p:cNvPr id="38" name="Text 36"/>
+          <p:cNvSpPr txBox="1"/>
+          <p:nvPr/>
+        </p:nvSpPr>
+        <p:spPr>
+          <a:xfrm>
+            <a:off x="1234440" y="5760720"/>
+            <a:ext cx="4526280" cy="548640"/>
+          </a:xfrm>
+          <a:prstGeom prst="rect">
+            <a:avLst/>
+          </a:prstGeom>
+          <a:noFill/>
+          <a:ln/>
+        </p:spPr>
+        <p:txBody>
+          <a:bodyPr wrap="square" lIns="0" tIns="0" rIns="0" bIns="0" rtlCol="0" anchor="ctr"/>
+          <a:lstStyle/>
+          <a:p>
+            <a:pPr indent="0" marL="0">
+              <a:buNone/>
+            </a:pPr>
+            <a:r>
+              <a:rPr lang="en-US" sz="1000" dirty="0">
+                <a:solidFill>
+                  <a:srgbClr val="CADCFC"/>
+                </a:solidFill>
+                <a:latin typeface="Calibri" pitchFamily="34" charset="0"/>
+                <a:ea typeface="Calibri" pitchFamily="34" charset="-122"/>
+                <a:cs typeface="Calibri" pitchFamily="34" charset="-120"/>
+              </a:rPr>
+              <a:t>Alembic replaces create_all(); older databases are adopted with their data</a:t>
+            </a:r>
+            <a:endParaRPr lang="en-US" sz="1000" dirty="0"/>
+          </a:p>
+        </p:txBody>
+      </p:sp>
+      <p:sp>
+        <p:nvSpPr>
+          <p:cNvPr id="39" name="Shape 37"/>
+          <p:cNvSpPr/>
+          <p:nvPr/>
+        </p:nvSpPr>
+        <p:spPr>
+          <a:xfrm>
+            <a:off x="6217920" y="5340096"/>
+            <a:ext cx="5394960" cy="1051560"/>
+          </a:xfrm>
+          <a:prstGeom prst="roundRect">
+            <a:avLst>
+              <a:gd name="adj" fmla="val 6957"/>
+            </a:avLst>
+          </a:prstGeom>
+          <a:solidFill>
+            <a:srgbClr val="1E293B"/>
+          </a:solidFill>
+          <a:ln/>
+        </p:spPr>
+        <p:txBody>
+          <a:bodyPr/>
+          <a:p/>
+        </p:txBody>
+      </p:sp>
+      <p:sp>
+        <p:nvSpPr>
+          <p:cNvPr id="40" name="Shape 38"/>
+          <p:cNvSpPr/>
+          <p:nvPr/>
+        </p:nvSpPr>
+        <p:spPr>
+          <a:xfrm>
+            <a:off x="6382512" y="5504688"/>
+            <a:ext cx="365760" cy="365760"/>
+          </a:xfrm>
+          <a:prstGeom prst="ellipse">
+            <a:avLst/>
+          </a:prstGeom>
+          <a:solidFill>
+            <a:srgbClr val="16A34A"/>
+          </a:solidFill>
+          <a:ln/>
+        </p:spPr>
+        <p:txBody>
+          <a:bodyPr/>
+          <a:p/>
+        </p:txBody>
+      </p:sp>
+      <p:sp>
+        <p:nvSpPr>
+          <p:cNvPr id="41" name="Text 39"/>
+          <p:cNvSpPr txBox="1"/>
+          <p:nvPr/>
+        </p:nvSpPr>
+        <p:spPr>
+          <a:xfrm>
+            <a:off x="6382512" y="5504688"/>
+            <a:ext cx="365760" cy="365760"/>
+          </a:xfrm>
+          <a:prstGeom prst="rect">
+            <a:avLst/>
+          </a:prstGeom>
+          <a:noFill/>
+          <a:ln/>
+        </p:spPr>
+        <p:txBody>
+          <a:bodyPr wrap="square" lIns="0" tIns="0" rIns="0" bIns="0" rtlCol="0" anchor="ctr"/>
+          <a:lstStyle/>
+          <a:p>
+            <a:pPr algn="ctr" indent="0" marL="0">
+              <a:buNone/>
+            </a:pPr>
+            <a:r>
+              <a:rPr lang="en-US" sz="1600" b="1" dirty="0">
+                <a:solidFill>
+                  <a:srgbClr val="FFFFFF"/>
+                </a:solidFill>
+                <a:latin typeface="Cambria" pitchFamily="34" charset="0"/>
+                <a:ea typeface="Cambria" pitchFamily="34" charset="-122"/>
+                <a:cs typeface="Cambria" pitchFamily="34" charset="-120"/>
+              </a:rPr>
+              <a:t>✓</a:t>
+            </a:r>
+            <a:endParaRPr lang="en-US" sz="1600" dirty="0"/>
+          </a:p>
+        </p:txBody>
+      </p:sp>
+      <p:sp>
+        <p:nvSpPr>
+          <p:cNvPr id="42" name="Text 40"/>
+          <p:cNvSpPr txBox="1"/>
+          <p:nvPr/>
+        </p:nvSpPr>
+        <p:spPr>
+          <a:xfrm>
+            <a:off x="6903720" y="5431536"/>
+            <a:ext cx="4526280" cy="320040"/>
+          </a:xfrm>
+          <a:prstGeom prst="rect">
+            <a:avLst/>
+          </a:prstGeom>
+          <a:noFill/>
+          <a:ln/>
+        </p:spPr>
+        <p:txBody>
+          <a:bodyPr wrap="square" lIns="0" tIns="0" rIns="0" bIns="0" rtlCol="0" anchor="ctr"/>
+          <a:lstStyle/>
+          <a:p>
+            <a:pPr indent="0" marL="0">
+              <a:buNone/>
+            </a:pPr>
+            <a:r>
+              <a:rPr lang="en-US" sz="1300" b="1" dirty="0">
+                <a:solidFill>
+                  <a:srgbClr val="FFFFFF"/>
+                </a:solidFill>
+                <a:latin typeface="Calibri" pitchFamily="34" charset="0"/>
+                <a:ea typeface="Calibri" pitchFamily="34" charset="-122"/>
+                <a:cs typeface="Calibri" pitchFamily="34" charset="-120"/>
+              </a:rPr>
+              <a:t>Cloud file storage</a:t>
+            </a:r>
+            <a:endParaRPr lang="en-US" sz="1300" dirty="0"/>
+          </a:p>
+        </p:txBody>
+      </p:sp>
+      <p:sp>
+        <p:nvSpPr>
+          <p:cNvPr id="43" name="Text 41"/>
+          <p:cNvSpPr txBox="1"/>
+          <p:nvPr/>
+        </p:nvSpPr>
+        <p:spPr>
+          <a:xfrm>
+            <a:off x="6903720" y="5760720"/>
+            <a:ext cx="4526280" cy="548640"/>
+          </a:xfrm>
+          <a:prstGeom prst="rect">
+            <a:avLst/>
+          </a:prstGeom>
+          <a:noFill/>
+          <a:ln/>
+        </p:spPr>
+        <p:txBody>
+          <a:bodyPr wrap="square" lIns="0" tIns="0" rIns="0" bIns="0" rtlCol="0" anchor="ctr"/>
+          <a:lstStyle/>
+          <a:p>
+            <a:pPr indent="0" marL="0">
+              <a:buNone/>
+            </a:pPr>
+            <a:r>
+              <a:rPr lang="en-US" sz="1000" dirty="0">
+                <a:solidFill>
+                  <a:srgbClr val="CADCFC"/>
+                </a:solidFill>
+                <a:latin typeface="Calibri" pitchFamily="34" charset="0"/>
+                <a:ea typeface="Calibri" pitchFamily="34" charset="-122"/>
+                <a:cs typeface="Calibri" pitchFamily="34" charset="-120"/>
+              </a:rPr>
+              <a:t>Uploads can live in an S3-compatible bucket and survive redeploys</a:t>
+            </a:r>
+            <a:endParaRPr lang="en-US" sz="1000" dirty="0"/>
+          </a:p>
+        </p:txBody>
+      </p:sp>
+      <p:sp>
+        <p:nvSpPr>
+          <p:cNvPr id="44" name="Text 42"/>
+          <p:cNvSpPr txBox="1"/>
+          <p:nvPr/>
+        </p:nvSpPr>
+        <p:spPr>
+          <a:xfrm>
+            <a:off x="457200" y="6528816"/>
+            <a:ext cx="7315200" cy="274320"/>
+          </a:xfrm>
+          <a:prstGeom prst="rect">
+            <a:avLst/>
+          </a:prstGeom>
+          <a:noFill/>
+          <a:ln/>
+        </p:spPr>
+        <p:txBody>
+          <a:bodyPr wrap="square" lIns="0" tIns="0" rIns="0" bIns="0" rtlCol="0" anchor="ctr"/>
+          <a:lstStyle/>
+          <a:p>
+            <a:pPr indent="0" marL="0">
+              <a:buNone/>
+            </a:pPr>
+            <a:r>
+              <a:rPr lang="en-US" sz="1000" dirty="0">
+                <a:solidFill>
+                  <a:srgbClr val="475569"/>
+                </a:solidFill>
+                <a:latin typeface="Calibri" pitchFamily="34" charset="0"/>
+                <a:ea typeface="Calibri" pitchFamily="34" charset="-122"/>
+                <a:cs typeface="Calibri" pitchFamily="34" charset="-120"/>
+              </a:rPr>
+              <a:t>Extended Scope — Full Arabic &amp; Hardening</a:t>
+            </a:r>
+            <a:endParaRPr lang="en-US" sz="1000" dirty="0"/>
+          </a:p>
+        </p:txBody>
+      </p:sp>
+      <p:sp>
+        <p:nvSpPr>
+          <p:cNvPr id="45" name="Text 43"/>
+          <p:cNvSpPr txBox="1"/>
+          <p:nvPr/>
+        </p:nvSpPr>
+        <p:spPr>
+          <a:xfrm>
+            <a:off x="11247120" y="6528816"/>
+            <a:ext cx="548640" cy="274320"/>
+          </a:xfrm>
+          <a:prstGeom prst="rect">
+            <a:avLst/>
+          </a:prstGeom>
+          <a:noFill/>
+          <a:ln/>
+        </p:spPr>
+        <p:txBody>
+          <a:bodyPr wrap="square" lIns="0" tIns="0" rIns="0" bIns="0" rtlCol="0" anchor="ctr"/>
+          <a:lstStyle/>
+          <a:p>
+            <a:pPr algn="r" indent="0" marL="0">
+              <a:buNone/>
+            </a:pPr>
+            <a:r>
+              <a:rPr lang="en-US" sz="1000" dirty="0">
+                <a:solidFill>
+                  <a:srgbClr val="475569"/>
+                </a:solidFill>
+                <a:latin typeface="Calibri" pitchFamily="34" charset="0"/>
+                <a:ea typeface="Calibri" pitchFamily="34" charset="-122"/>
+                <a:cs typeface="Calibri" pitchFamily="34" charset="-120"/>
+              </a:rPr>
+              <a:t>11 / 19</a:t>
+            </a:r>
+            <a:endParaRPr lang="en-US" sz="1000" dirty="0"/>
+          </a:p>
+        </p:txBody>
+      </p:sp>
+    </p:spTree>
+  </p:cSld>
+  <p:clrMapOvr>
+    <a:masterClrMapping/>
+  </p:clrMapOvr>
+</p:sld>
+</file>
+
+<file path=ppt/slides/slide12.xml><?xml version="1.0" encoding="utf-8"?>
 <p:sld xmlns:a="http://schemas.openxmlformats.org/drawingml/2006/main" xmlns:r="http://schemas.openxmlformats.org/officeDocument/2006/relationships" xmlns:p="http://schemas.openxmlformats.org/presentationml/2006/main">
   <p:cSld name="Slide 11">
     <p:bg>
@@ -4894,7 +6409,7 @@
 </p:sld>
 </file>
 
-<file path=ppt/slides/slide12.xml><?xml version="1.0" encoding="utf-8"?>
+<file path=ppt/slides/slide13.xml><?xml version="1.0" encoding="utf-8"?>
 <p:sld xmlns:a="http://schemas.openxmlformats.org/drawingml/2006/main" xmlns:r="http://schemas.openxmlformats.org/officeDocument/2006/relationships" xmlns:p="http://schemas.openxmlformats.org/presentationml/2006/main">
   <p:cSld name="Slide 10">
     <p:spTree>
@@ -5848,7 +7363,7 @@
 </p:sld>
 </file>
 
-<file path=ppt/slides/slide13.xml><?xml version="1.0" encoding="utf-8"?>
+<file path=ppt/slides/slide14.xml><?xml version="1.0" encoding="utf-8"?>
 <p:sld xmlns:a="http://schemas.openxmlformats.org/drawingml/2006/main" xmlns:r="http://schemas.openxmlformats.org/officeDocument/2006/relationships" xmlns:p="http://schemas.openxmlformats.org/presentationml/2006/main">
   <p:cSld name="Slide 11">
     <p:bg>
@@ -6672,7 +8187,7 @@
 </p:sld>
 </file>
 
-<file path=ppt/slides/slide14.xml><?xml version="1.0" encoding="utf-8"?>
+<file path=ppt/slides/slide15.xml><?xml version="1.0" encoding="utf-8"?>
 <p:sld xmlns:a="http://schemas.openxmlformats.org/drawingml/2006/main" xmlns:r="http://schemas.openxmlformats.org/officeDocument/2006/relationships" xmlns:p="http://schemas.openxmlformats.org/presentationml/2006/main">
   <p:cSld name="Slide 12">
     <p:spTree>
@@ -7438,7 +8953,7 @@
 </p:sld>
 </file>
 
-<file path=ppt/slides/slide15.xml><?xml version="1.0" encoding="utf-8"?>
+<file path=ppt/slides/slide16.xml><?xml version="1.0" encoding="utf-8"?>
 <p:sld xmlns:a="http://schemas.openxmlformats.org/drawingml/2006/main" xmlns:r="http://schemas.openxmlformats.org/officeDocument/2006/relationships" xmlns:p="http://schemas.openxmlformats.org/presentationml/2006/main">
   <p:cSld name="Slide 13">
     <p:spTree>
@@ -8916,7 +10431,7 @@
 </p:sld>
 </file>
 
-<file path=ppt/slides/slide16.xml><?xml version="1.0" encoding="utf-8"?>
+<file path=ppt/slides/slide17.xml><?xml version="1.0" encoding="utf-8"?>
 <p:sld xmlns:a="http://schemas.openxmlformats.org/drawingml/2006/main" xmlns:r="http://schemas.openxmlformats.org/officeDocument/2006/relationships" xmlns:p="http://schemas.openxmlformats.org/presentationml/2006/main">
   <p:cSld name="Slide 14">
     <p:bg>
@@ -9420,7 +10935,7 @@
                 <a:ea typeface="Calibri" pitchFamily="34" charset="-122"/>
                 <a:cs typeface="Calibri" pitchFamily="34" charset="-120"/>
               </a:rPr>
-              <a:t>8 feature gaps closed in Deliverable 5, a billing engine, and English/Shona/Arabic across every screen and document</a:t>
+              <a:t>11 feature gaps closed in Deliverable 5, a billing engine, and English/Shona/Arabic across every screen and document</a:t>
             </a:r>
             <a:endParaRPr lang="en-US" sz="1400" dirty="0"/>
           </a:p>
@@ -9679,7 +11194,7 @@
 </p:sld>
 </file>
 
-<file path=ppt/slides/slide17.xml><?xml version="1.0" encoding="utf-8"?>
+<file path=ppt/slides/slide18.xml><?xml version="1.0" encoding="utf-8"?>
 <p:sld xmlns:a="http://schemas.openxmlformats.org/drawingml/2006/main" xmlns:r="http://schemas.openxmlformats.org/officeDocument/2006/relationships" xmlns:p="http://schemas.openxmlformats.org/presentationml/2006/main">
   <p:cSld name="Slide 15">
     <p:spTree>
@@ -10705,7 +12220,7 @@
 </p:sld>
 </file>
 
-<file path=ppt/slides/slide18.xml><?xml version="1.0" encoding="utf-8"?>
+<file path=ppt/slides/slide19.xml><?xml version="1.0" encoding="utf-8"?>
 <p:sld xmlns:a="http://schemas.openxmlformats.org/drawingml/2006/main" xmlns:r="http://schemas.openxmlformats.org/officeDocument/2006/relationships" xmlns:p="http://schemas.openxmlformats.org/presentationml/2006/main">
   <p:cSld name="Slide 16">
     <p:bg>
@@ -10891,1523 +12406,6 @@
               <a:t>RentalPro — Digital Rental Management System  ·  IT401 Capstone</a:t>
             </a:r>
             <a:endParaRPr lang="en-US" sz="1200" dirty="0"/>
-          </a:p>
-        </p:txBody>
-      </p:sp>
-    </p:spTree>
-  </p:cSld>
-  <p:clrMapOvr>
-    <a:masterClrMapping/>
-  </p:clrMapOvr>
-</p:sld>
-</file>
-
-<file path=ppt/slides/slide19.xml><?xml version="1.0" encoding="utf-8"?>
-<p:sld xmlns:a="http://schemas.openxmlformats.org/drawingml/2006/main" xmlns:p="http://schemas.openxmlformats.org/presentationml/2006/main" xmlns:r="http://schemas.openxmlformats.org/officeDocument/2006/relationships">
-  <p:cSld>
-    <p:bg>
-      <p:bgPr>
-        <a:solidFill>
-          <a:srgbClr val="0F172A"/>
-        </a:solidFill>
-      </p:bgPr>
-    </p:bg>
-    <p:spTree>
-      <p:nvGrpSpPr>
-        <p:cNvPr id="1" name=""/>
-        <p:cNvGrpSpPr/>
-        <p:nvPr/>
-      </p:nvGrpSpPr>
-      <p:grpSpPr/>
-      <p:sp>
-        <p:nvSpPr>
-          <p:cNvPr id="2" name="Text 0"/>
-          <p:cNvSpPr txBox="1"/>
-          <p:nvPr/>
-        </p:nvSpPr>
-        <p:spPr>
-          <a:xfrm>
-            <a:off x="548640" y="457200"/>
-            <a:ext cx="10515600" cy="640080"/>
-          </a:xfrm>
-          <a:prstGeom prst="rect">
-            <a:avLst/>
-          </a:prstGeom>
-          <a:noFill/>
-          <a:ln/>
-        </p:spPr>
-        <p:txBody>
-          <a:bodyPr wrap="square" lIns="0" tIns="0" rIns="0" bIns="0" rtlCol="0" anchor="ctr"/>
-          <a:lstStyle/>
-          <a:p>
-            <a:pPr indent="0" marL="0">
-              <a:buNone/>
-            </a:pPr>
-            <a:r>
-              <a:rPr lang="en-US" sz="2800" b="1" dirty="0">
-                <a:solidFill>
-                  <a:srgbClr val="FFFFFF"/>
-                </a:solidFill>
-                <a:latin typeface="Cambria" pitchFamily="34" charset="0"/>
-                <a:ea typeface="Cambria" pitchFamily="34" charset="-122"/>
-                <a:cs typeface="Cambria" pitchFamily="34" charset="-120"/>
-              </a:rPr>
-              <a:t>Extended Scope — Full Arabic &amp; Production Hardening</a:t>
-            </a:r>
-            <a:endParaRPr lang="en-US" sz="2800" dirty="0"/>
-          </a:p>
-        </p:txBody>
-      </p:sp>
-      <p:sp>
-        <p:nvSpPr>
-          <p:cNvPr id="3" name="Text 1"/>
-          <p:cNvSpPr txBox="1"/>
-          <p:nvPr/>
-        </p:nvSpPr>
-        <p:spPr>
-          <a:xfrm>
-            <a:off x="548640" y="1097280"/>
-            <a:ext cx="10515600" cy="365760"/>
-          </a:xfrm>
-          <a:prstGeom prst="rect">
-            <a:avLst/>
-          </a:prstGeom>
-          <a:noFill/>
-          <a:ln/>
-        </p:spPr>
-        <p:txBody>
-          <a:bodyPr wrap="square" lIns="0" tIns="0" rIns="0" bIns="0" rtlCol="0" anchor="ctr"/>
-          <a:lstStyle/>
-          <a:p>
-            <a:pPr indent="0" marL="0">
-              <a:buNone/>
-            </a:pPr>
-            <a:r>
-              <a:rPr lang="en-US" sz="1350" dirty="0">
-                <a:solidFill>
-                  <a:srgbClr val="CADCFC"/>
-                </a:solidFill>
-                <a:latin typeface="Calibri" pitchFamily="34" charset="0"/>
-                <a:ea typeface="Calibri" pitchFamily="34" charset="-122"/>
-                <a:cs typeface="Calibri" pitchFamily="34" charset="-120"/>
-              </a:rPr>
-              <a:t>The final round: every word in Arabic, a stricter security posture and production-ready data handling — 54 more tests, all passing.</a:t>
-            </a:r>
-            <a:endParaRPr lang="en-US" sz="1350" dirty="0"/>
-          </a:p>
-        </p:txBody>
-      </p:sp>
-      <p:sp>
-        <p:nvSpPr>
-          <p:cNvPr id="4" name="Shape 2"/>
-          <p:cNvSpPr/>
-          <p:nvPr/>
-        </p:nvSpPr>
-        <p:spPr>
-          <a:xfrm>
-            <a:off x="548640" y="1691640"/>
-            <a:ext cx="5394960" cy="1051560"/>
-          </a:xfrm>
-          <a:prstGeom prst="roundRect">
-            <a:avLst>
-              <a:gd name="adj" fmla="val 6957"/>
-            </a:avLst>
-          </a:prstGeom>
-          <a:solidFill>
-            <a:srgbClr val="1E293B"/>
-          </a:solidFill>
-          <a:ln/>
-        </p:spPr>
-        <p:txBody>
-          <a:bodyPr/>
-          <a:p/>
-        </p:txBody>
-      </p:sp>
-      <p:sp>
-        <p:nvSpPr>
-          <p:cNvPr id="5" name="Shape 3"/>
-          <p:cNvSpPr/>
-          <p:nvPr/>
-        </p:nvSpPr>
-        <p:spPr>
-          <a:xfrm>
-            <a:off x="713232" y="1856232"/>
-            <a:ext cx="365760" cy="365760"/>
-          </a:xfrm>
-          <a:prstGeom prst="ellipse">
-            <a:avLst/>
-          </a:prstGeom>
-          <a:solidFill>
-            <a:srgbClr val="16A34A"/>
-          </a:solidFill>
-          <a:ln/>
-        </p:spPr>
-        <p:txBody>
-          <a:bodyPr/>
-          <a:p/>
-        </p:txBody>
-      </p:sp>
-      <p:sp>
-        <p:nvSpPr>
-          <p:cNvPr id="6" name="Text 4"/>
-          <p:cNvSpPr txBox="1"/>
-          <p:nvPr/>
-        </p:nvSpPr>
-        <p:spPr>
-          <a:xfrm>
-            <a:off x="713232" y="1856232"/>
-            <a:ext cx="365760" cy="365760"/>
-          </a:xfrm>
-          <a:prstGeom prst="rect">
-            <a:avLst/>
-          </a:prstGeom>
-          <a:noFill/>
-          <a:ln/>
-        </p:spPr>
-        <p:txBody>
-          <a:bodyPr wrap="square" lIns="0" tIns="0" rIns="0" bIns="0" rtlCol="0" anchor="ctr"/>
-          <a:lstStyle/>
-          <a:p>
-            <a:pPr algn="ctr" indent="0" marL="0">
-              <a:buNone/>
-            </a:pPr>
-            <a:r>
-              <a:rPr lang="en-US" sz="1600" b="1" dirty="0">
-                <a:solidFill>
-                  <a:srgbClr val="FFFFFF"/>
-                </a:solidFill>
-                <a:latin typeface="Cambria" pitchFamily="34" charset="0"/>
-                <a:ea typeface="Cambria" pitchFamily="34" charset="-122"/>
-                <a:cs typeface="Cambria" pitchFamily="34" charset="-120"/>
-              </a:rPr>
-              <a:t>✓</a:t>
-            </a:r>
-            <a:endParaRPr lang="en-US" sz="1600" dirty="0"/>
-          </a:p>
-        </p:txBody>
-      </p:sp>
-      <p:sp>
-        <p:nvSpPr>
-          <p:cNvPr id="7" name="Text 5"/>
-          <p:cNvSpPr txBox="1"/>
-          <p:nvPr/>
-        </p:nvSpPr>
-        <p:spPr>
-          <a:xfrm>
-            <a:off x="1234440" y="1783080"/>
-            <a:ext cx="4526280" cy="320040"/>
-          </a:xfrm>
-          <a:prstGeom prst="rect">
-            <a:avLst/>
-          </a:prstGeom>
-          <a:noFill/>
-          <a:ln/>
-        </p:spPr>
-        <p:txBody>
-          <a:bodyPr wrap="square" lIns="0" tIns="0" rIns="0" bIns="0" rtlCol="0" anchor="ctr"/>
-          <a:lstStyle/>
-          <a:p>
-            <a:pPr indent="0" marL="0">
-              <a:buNone/>
-            </a:pPr>
-            <a:r>
-              <a:rPr lang="en-US" sz="1300" b="1" dirty="0">
-                <a:solidFill>
-                  <a:srgbClr val="FFFFFF"/>
-                </a:solidFill>
-                <a:latin typeface="Calibri" pitchFamily="34" charset="0"/>
-                <a:ea typeface="Calibri" pitchFamily="34" charset="-122"/>
-                <a:cs typeface="Calibri" pitchFamily="34" charset="-120"/>
-              </a:rPr>
-              <a:t>Arabic on every screen</a:t>
-            </a:r>
-            <a:endParaRPr lang="en-US" sz="1300" dirty="0"/>
-          </a:p>
-        </p:txBody>
-      </p:sp>
-      <p:sp>
-        <p:nvSpPr>
-          <p:cNvPr id="8" name="Text 6"/>
-          <p:cNvSpPr txBox="1"/>
-          <p:nvPr/>
-        </p:nvSpPr>
-        <p:spPr>
-          <a:xfrm>
-            <a:off x="1234440" y="2112264"/>
-            <a:ext cx="4526280" cy="548640"/>
-          </a:xfrm>
-          <a:prstGeom prst="rect">
-            <a:avLst/>
-          </a:prstGeom>
-          <a:noFill/>
-          <a:ln/>
-        </p:spPr>
-        <p:txBody>
-          <a:bodyPr wrap="square" lIns="0" tIns="0" rIns="0" bIns="0" rtlCol="0" anchor="ctr"/>
-          <a:lstStyle/>
-          <a:p>
-            <a:pPr indent="0" marL="0">
-              <a:buNone/>
-            </a:pPr>
-            <a:r>
-              <a:rPr lang="en-US" sz="1000" dirty="0">
-                <a:solidFill>
-                  <a:srgbClr val="CADCFC"/>
-                </a:solidFill>
-                <a:latin typeface="Calibri" pitchFamily="34" charset="0"/>
-                <a:ea typeface="Calibri" pitchFamily="34" charset="-122"/>
-                <a:cs typeface="Calibri" pitchFamily="34" charset="-120"/>
-              </a:rPr>
-              <a:t>Every page, form option and message — over 600 phrases; a test fails if one is missing</a:t>
-            </a:r>
-            <a:endParaRPr lang="en-US" sz="1000" dirty="0"/>
-          </a:p>
-        </p:txBody>
-      </p:sp>
-      <p:sp>
-        <p:nvSpPr>
-          <p:cNvPr id="9" name="Shape 7"/>
-          <p:cNvSpPr/>
-          <p:nvPr/>
-        </p:nvSpPr>
-        <p:spPr>
-          <a:xfrm>
-            <a:off x="6217920" y="1691640"/>
-            <a:ext cx="5394960" cy="1051560"/>
-          </a:xfrm>
-          <a:prstGeom prst="roundRect">
-            <a:avLst>
-              <a:gd name="adj" fmla="val 6957"/>
-            </a:avLst>
-          </a:prstGeom>
-          <a:solidFill>
-            <a:srgbClr val="1E293B"/>
-          </a:solidFill>
-          <a:ln/>
-        </p:spPr>
-        <p:txBody>
-          <a:bodyPr/>
-          <a:p/>
-        </p:txBody>
-      </p:sp>
-      <p:sp>
-        <p:nvSpPr>
-          <p:cNvPr id="10" name="Shape 8"/>
-          <p:cNvSpPr/>
-          <p:nvPr/>
-        </p:nvSpPr>
-        <p:spPr>
-          <a:xfrm>
-            <a:off x="6382512" y="1856232"/>
-            <a:ext cx="365760" cy="365760"/>
-          </a:xfrm>
-          <a:prstGeom prst="ellipse">
-            <a:avLst/>
-          </a:prstGeom>
-          <a:solidFill>
-            <a:srgbClr val="16A34A"/>
-          </a:solidFill>
-          <a:ln/>
-        </p:spPr>
-        <p:txBody>
-          <a:bodyPr/>
-          <a:p/>
-        </p:txBody>
-      </p:sp>
-      <p:sp>
-        <p:nvSpPr>
-          <p:cNvPr id="11" name="Text 9"/>
-          <p:cNvSpPr txBox="1"/>
-          <p:nvPr/>
-        </p:nvSpPr>
-        <p:spPr>
-          <a:xfrm>
-            <a:off x="6382512" y="1856232"/>
-            <a:ext cx="365760" cy="365760"/>
-          </a:xfrm>
-          <a:prstGeom prst="rect">
-            <a:avLst/>
-          </a:prstGeom>
-          <a:noFill/>
-          <a:ln/>
-        </p:spPr>
-        <p:txBody>
-          <a:bodyPr wrap="square" lIns="0" tIns="0" rIns="0" bIns="0" rtlCol="0" anchor="ctr"/>
-          <a:lstStyle/>
-          <a:p>
-            <a:pPr algn="ctr" indent="0" marL="0">
-              <a:buNone/>
-            </a:pPr>
-            <a:r>
-              <a:rPr lang="en-US" sz="1600" b="1" dirty="0">
-                <a:solidFill>
-                  <a:srgbClr val="FFFFFF"/>
-                </a:solidFill>
-                <a:latin typeface="Cambria" pitchFamily="34" charset="0"/>
-                <a:ea typeface="Cambria" pitchFamily="34" charset="-122"/>
-                <a:cs typeface="Cambria" pitchFamily="34" charset="-120"/>
-              </a:rPr>
-              <a:t>✓</a:t>
-            </a:r>
-            <a:endParaRPr lang="en-US" sz="1600" dirty="0"/>
-          </a:p>
-        </p:txBody>
-      </p:sp>
-      <p:sp>
-        <p:nvSpPr>
-          <p:cNvPr id="12" name="Text 10"/>
-          <p:cNvSpPr txBox="1"/>
-          <p:nvPr/>
-        </p:nvSpPr>
-        <p:spPr>
-          <a:xfrm>
-            <a:off x="6903720" y="1783080"/>
-            <a:ext cx="4526280" cy="320040"/>
-          </a:xfrm>
-          <a:prstGeom prst="rect">
-            <a:avLst/>
-          </a:prstGeom>
-          <a:noFill/>
-          <a:ln/>
-        </p:spPr>
-        <p:txBody>
-          <a:bodyPr wrap="square" lIns="0" tIns="0" rIns="0" bIns="0" rtlCol="0" anchor="ctr"/>
-          <a:lstStyle/>
-          <a:p>
-            <a:pPr indent="0" marL="0">
-              <a:buNone/>
-            </a:pPr>
-            <a:r>
-              <a:rPr lang="en-US" sz="1300" b="1" dirty="0">
-                <a:solidFill>
-                  <a:srgbClr val="FFFFFF"/>
-                </a:solidFill>
-                <a:latin typeface="Calibri" pitchFamily="34" charset="0"/>
-                <a:ea typeface="Calibri" pitchFamily="34" charset="-122"/>
-                <a:cs typeface="Calibri" pitchFamily="34" charset="-120"/>
-              </a:rPr>
-              <a:t>Emails &amp; SMS in each user’s language</a:t>
-            </a:r>
-            <a:endParaRPr lang="en-US" sz="1300" dirty="0"/>
-          </a:p>
-        </p:txBody>
-      </p:sp>
-      <p:sp>
-        <p:nvSpPr>
-          <p:cNvPr id="13" name="Text 11"/>
-          <p:cNvSpPr txBox="1"/>
-          <p:nvPr/>
-        </p:nvSpPr>
-        <p:spPr>
-          <a:xfrm>
-            <a:off x="6903720" y="2112264"/>
-            <a:ext cx="4526280" cy="548640"/>
-          </a:xfrm>
-          <a:prstGeom prst="rect">
-            <a:avLst/>
-          </a:prstGeom>
-          <a:noFill/>
-          <a:ln/>
-        </p:spPr>
-        <p:txBody>
-          <a:bodyPr wrap="square" lIns="0" tIns="0" rIns="0" bIns="0" rtlCol="0" anchor="ctr"/>
-          <a:lstStyle/>
-          <a:p>
-            <a:pPr indent="0" marL="0">
-              <a:buNone/>
-            </a:pPr>
-            <a:r>
-              <a:rPr lang="en-US" sz="1000" dirty="0">
-                <a:solidFill>
-                  <a:srgbClr val="CADCFC"/>
-                </a:solidFill>
-                <a:latin typeface="Calibri" pitchFamily="34" charset="0"/>
-                <a:ea typeface="Calibri" pitchFamily="34" charset="-122"/>
-                <a:cs typeface="Calibri" pitchFamily="34" charset="-120"/>
-              </a:rPr>
-              <a:t>Sent in the language the user last chose, including by the nightly jobs</a:t>
-            </a:r>
-            <a:endParaRPr lang="en-US" sz="1000" dirty="0"/>
-          </a:p>
-        </p:txBody>
-      </p:sp>
-      <p:sp>
-        <p:nvSpPr>
-          <p:cNvPr id="14" name="Shape 12"/>
-          <p:cNvSpPr/>
-          <p:nvPr/>
-        </p:nvSpPr>
-        <p:spPr>
-          <a:xfrm>
-            <a:off x="548640" y="2907792"/>
-            <a:ext cx="5394960" cy="1051560"/>
-          </a:xfrm>
-          <a:prstGeom prst="roundRect">
-            <a:avLst>
-              <a:gd name="adj" fmla="val 6957"/>
-            </a:avLst>
-          </a:prstGeom>
-          <a:solidFill>
-            <a:srgbClr val="1E293B"/>
-          </a:solidFill>
-          <a:ln/>
-        </p:spPr>
-        <p:txBody>
-          <a:bodyPr/>
-          <a:p/>
-        </p:txBody>
-      </p:sp>
-      <p:sp>
-        <p:nvSpPr>
-          <p:cNvPr id="15" name="Shape 13"/>
-          <p:cNvSpPr/>
-          <p:nvPr/>
-        </p:nvSpPr>
-        <p:spPr>
-          <a:xfrm>
-            <a:off x="713232" y="3072384"/>
-            <a:ext cx="365760" cy="365760"/>
-          </a:xfrm>
-          <a:prstGeom prst="ellipse">
-            <a:avLst/>
-          </a:prstGeom>
-          <a:solidFill>
-            <a:srgbClr val="16A34A"/>
-          </a:solidFill>
-          <a:ln/>
-        </p:spPr>
-        <p:txBody>
-          <a:bodyPr/>
-          <a:p/>
-        </p:txBody>
-      </p:sp>
-      <p:sp>
-        <p:nvSpPr>
-          <p:cNvPr id="16" name="Text 14"/>
-          <p:cNvSpPr txBox="1"/>
-          <p:nvPr/>
-        </p:nvSpPr>
-        <p:spPr>
-          <a:xfrm>
-            <a:off x="713232" y="3072384"/>
-            <a:ext cx="365760" cy="365760"/>
-          </a:xfrm>
-          <a:prstGeom prst="rect">
-            <a:avLst/>
-          </a:prstGeom>
-          <a:noFill/>
-          <a:ln/>
-        </p:spPr>
-        <p:txBody>
-          <a:bodyPr wrap="square" lIns="0" tIns="0" rIns="0" bIns="0" rtlCol="0" anchor="ctr"/>
-          <a:lstStyle/>
-          <a:p>
-            <a:pPr algn="ctr" indent="0" marL="0">
-              <a:buNone/>
-            </a:pPr>
-            <a:r>
-              <a:rPr lang="en-US" sz="1600" b="1" dirty="0">
-                <a:solidFill>
-                  <a:srgbClr val="FFFFFF"/>
-                </a:solidFill>
-                <a:latin typeface="Cambria" pitchFamily="34" charset="0"/>
-                <a:ea typeface="Cambria" pitchFamily="34" charset="-122"/>
-                <a:cs typeface="Cambria" pitchFamily="34" charset="-120"/>
-              </a:rPr>
-              <a:t>✓</a:t>
-            </a:r>
-            <a:endParaRPr lang="en-US" sz="1600" dirty="0"/>
-          </a:p>
-        </p:txBody>
-      </p:sp>
-      <p:sp>
-        <p:nvSpPr>
-          <p:cNvPr id="17" name="Text 15"/>
-          <p:cNvSpPr txBox="1"/>
-          <p:nvPr/>
-        </p:nvSpPr>
-        <p:spPr>
-          <a:xfrm>
-            <a:off x="1234440" y="2999232"/>
-            <a:ext cx="4526280" cy="320040"/>
-          </a:xfrm>
-          <a:prstGeom prst="rect">
-            <a:avLst/>
-          </a:prstGeom>
-          <a:noFill/>
-          <a:ln/>
-        </p:spPr>
-        <p:txBody>
-          <a:bodyPr wrap="square" lIns="0" tIns="0" rIns="0" bIns="0" rtlCol="0" anchor="ctr"/>
-          <a:lstStyle/>
-          <a:p>
-            <a:pPr indent="0" marL="0">
-              <a:buNone/>
-            </a:pPr>
-            <a:r>
-              <a:rPr lang="en-US" sz="1300" b="1" dirty="0">
-                <a:solidFill>
-                  <a:srgbClr val="FFFFFF"/>
-                </a:solidFill>
-                <a:latin typeface="Calibri" pitchFamily="34" charset="0"/>
-                <a:ea typeface="Calibri" pitchFamily="34" charset="-122"/>
-                <a:cs typeface="Calibri" pitchFamily="34" charset="-120"/>
-              </a:rPr>
-              <a:t>Arabic PDFs &amp; spreadsheets</a:t>
-            </a:r>
-            <a:endParaRPr lang="en-US" sz="1300" dirty="0"/>
-          </a:p>
-        </p:txBody>
-      </p:sp>
-      <p:sp>
-        <p:nvSpPr>
-          <p:cNvPr id="18" name="Text 16"/>
-          <p:cNvSpPr txBox="1"/>
-          <p:nvPr/>
-        </p:nvSpPr>
-        <p:spPr>
-          <a:xfrm>
-            <a:off x="1234440" y="3328416"/>
-            <a:ext cx="4526280" cy="548640"/>
-          </a:xfrm>
-          <a:prstGeom prst="rect">
-            <a:avLst/>
-          </a:prstGeom>
-          <a:noFill/>
-          <a:ln/>
-        </p:spPr>
-        <p:txBody>
-          <a:bodyPr wrap="square" lIns="0" tIns="0" rIns="0" bIns="0" rtlCol="0" anchor="ctr"/>
-          <a:lstStyle/>
-          <a:p>
-            <a:pPr indent="0" marL="0">
-              <a:buNone/>
-            </a:pPr>
-            <a:r>
-              <a:rPr lang="en-US" sz="1000" dirty="0">
-                <a:solidFill>
-                  <a:srgbClr val="CADCFC"/>
-                </a:solidFill>
-                <a:latin typeface="Calibri" pitchFamily="34" charset="0"/>
-                <a:ea typeface="Calibri" pitchFamily="34" charset="-122"/>
-                <a:cs typeface="Calibri" pitchFamily="34" charset="-120"/>
-              </a:rPr>
-              <a:t>PDF letters joined and right to left, tables mirrored; Excel sheets open right to left</a:t>
-            </a:r>
-            <a:endParaRPr lang="en-US" sz="1000" dirty="0"/>
-          </a:p>
-        </p:txBody>
-      </p:sp>
-      <p:sp>
-        <p:nvSpPr>
-          <p:cNvPr id="19" name="Shape 17"/>
-          <p:cNvSpPr/>
-          <p:nvPr/>
-        </p:nvSpPr>
-        <p:spPr>
-          <a:xfrm>
-            <a:off x="6217920" y="2907792"/>
-            <a:ext cx="5394960" cy="1051560"/>
-          </a:xfrm>
-          <a:prstGeom prst="roundRect">
-            <a:avLst>
-              <a:gd name="adj" fmla="val 6957"/>
-            </a:avLst>
-          </a:prstGeom>
-          <a:solidFill>
-            <a:srgbClr val="1E293B"/>
-          </a:solidFill>
-          <a:ln/>
-        </p:spPr>
-        <p:txBody>
-          <a:bodyPr/>
-          <a:p/>
-        </p:txBody>
-      </p:sp>
-      <p:sp>
-        <p:nvSpPr>
-          <p:cNvPr id="20" name="Shape 18"/>
-          <p:cNvSpPr/>
-          <p:nvPr/>
-        </p:nvSpPr>
-        <p:spPr>
-          <a:xfrm>
-            <a:off x="6382512" y="3072384"/>
-            <a:ext cx="365760" cy="365760"/>
-          </a:xfrm>
-          <a:prstGeom prst="ellipse">
-            <a:avLst/>
-          </a:prstGeom>
-          <a:solidFill>
-            <a:srgbClr val="16A34A"/>
-          </a:solidFill>
-          <a:ln/>
-        </p:spPr>
-        <p:txBody>
-          <a:bodyPr/>
-          <a:p/>
-        </p:txBody>
-      </p:sp>
-      <p:sp>
-        <p:nvSpPr>
-          <p:cNvPr id="21" name="Text 19"/>
-          <p:cNvSpPr txBox="1"/>
-          <p:nvPr/>
-        </p:nvSpPr>
-        <p:spPr>
-          <a:xfrm>
-            <a:off x="6382512" y="3072384"/>
-            <a:ext cx="365760" cy="365760"/>
-          </a:xfrm>
-          <a:prstGeom prst="rect">
-            <a:avLst/>
-          </a:prstGeom>
-          <a:noFill/>
-          <a:ln/>
-        </p:spPr>
-        <p:txBody>
-          <a:bodyPr wrap="square" lIns="0" tIns="0" rIns="0" bIns="0" rtlCol="0" anchor="ctr"/>
-          <a:lstStyle/>
-          <a:p>
-            <a:pPr algn="ctr" indent="0" marL="0">
-              <a:buNone/>
-            </a:pPr>
-            <a:r>
-              <a:rPr lang="en-US" sz="1600" b="1" dirty="0">
-                <a:solidFill>
-                  <a:srgbClr val="FFFFFF"/>
-                </a:solidFill>
-                <a:latin typeface="Cambria" pitchFamily="34" charset="0"/>
-                <a:ea typeface="Cambria" pitchFamily="34" charset="-122"/>
-                <a:cs typeface="Cambria" pitchFamily="34" charset="-120"/>
-              </a:rPr>
-              <a:t>✓</a:t>
-            </a:r>
-            <a:endParaRPr lang="en-US" sz="1600" dirty="0"/>
-          </a:p>
-        </p:txBody>
-      </p:sp>
-      <p:sp>
-        <p:nvSpPr>
-          <p:cNvPr id="22" name="Text 20"/>
-          <p:cNvSpPr txBox="1"/>
-          <p:nvPr/>
-        </p:nvSpPr>
-        <p:spPr>
-          <a:xfrm>
-            <a:off x="6903720" y="2999232"/>
-            <a:ext cx="4526280" cy="320040"/>
-          </a:xfrm>
-          <a:prstGeom prst="rect">
-            <a:avLst/>
-          </a:prstGeom>
-          <a:noFill/>
-          <a:ln/>
-        </p:spPr>
-        <p:txBody>
-          <a:bodyPr wrap="square" lIns="0" tIns="0" rIns="0" bIns="0" rtlCol="0" anchor="ctr"/>
-          <a:lstStyle/>
-          <a:p>
-            <a:pPr indent="0" marL="0">
-              <a:buNone/>
-            </a:pPr>
-            <a:r>
-              <a:rPr lang="en-US" sz="1300" b="1" dirty="0">
-                <a:solidFill>
-                  <a:srgbClr val="FFFFFF"/>
-                </a:solidFill>
-                <a:latin typeface="Calibri" pitchFamily="34" charset="0"/>
-                <a:ea typeface="Calibri" pitchFamily="34" charset="-122"/>
-                <a:cs typeface="Calibri" pitchFamily="34" charset="-120"/>
-              </a:rPr>
-              <a:t>Currency everywhere</a:t>
-            </a:r>
-            <a:endParaRPr lang="en-US" sz="1300" dirty="0"/>
-          </a:p>
-        </p:txBody>
-      </p:sp>
-      <p:sp>
-        <p:nvSpPr>
-          <p:cNvPr id="23" name="Text 21"/>
-          <p:cNvSpPr txBox="1"/>
-          <p:nvPr/>
-        </p:nvSpPr>
-        <p:spPr>
-          <a:xfrm>
-            <a:off x="6903720" y="3328416"/>
-            <a:ext cx="4526280" cy="548640"/>
-          </a:xfrm>
-          <a:prstGeom prst="rect">
-            <a:avLst/>
-          </a:prstGeom>
-          <a:noFill/>
-          <a:ln/>
-        </p:spPr>
-        <p:txBody>
-          <a:bodyPr wrap="square" lIns="0" tIns="0" rIns="0" bIns="0" rtlCol="0" anchor="ctr"/>
-          <a:lstStyle/>
-          <a:p>
-            <a:pPr indent="0" marL="0">
-              <a:buNone/>
-            </a:pPr>
-            <a:r>
-              <a:rPr lang="en-US" sz="1000" dirty="0">
-                <a:solidFill>
-                  <a:srgbClr val="CADCFC"/>
-                </a:solidFill>
-                <a:latin typeface="Calibri" pitchFamily="34" charset="0"/>
-                <a:ea typeface="Calibri" pitchFamily="34" charset="-122"/>
-                <a:cs typeface="Calibri" pitchFamily="34" charset="-120"/>
-              </a:rPr>
-              <a:t>Every amount shown as “USD 1,250.00” — screens, messages, emails and PDFs</a:t>
-            </a:r>
-            <a:endParaRPr lang="en-US" sz="1000" dirty="0"/>
-          </a:p>
-        </p:txBody>
-      </p:sp>
-      <p:sp>
-        <p:nvSpPr>
-          <p:cNvPr id="24" name="Shape 22"/>
-          <p:cNvSpPr/>
-          <p:nvPr/>
-        </p:nvSpPr>
-        <p:spPr>
-          <a:xfrm>
-            <a:off x="548640" y="4123944"/>
-            <a:ext cx="5394960" cy="1051560"/>
-          </a:xfrm>
-          <a:prstGeom prst="roundRect">
-            <a:avLst>
-              <a:gd name="adj" fmla="val 6957"/>
-            </a:avLst>
-          </a:prstGeom>
-          <a:solidFill>
-            <a:srgbClr val="1E293B"/>
-          </a:solidFill>
-          <a:ln/>
-        </p:spPr>
-        <p:txBody>
-          <a:bodyPr/>
-          <a:p/>
-        </p:txBody>
-      </p:sp>
-      <p:sp>
-        <p:nvSpPr>
-          <p:cNvPr id="25" name="Shape 23"/>
-          <p:cNvSpPr/>
-          <p:nvPr/>
-        </p:nvSpPr>
-        <p:spPr>
-          <a:xfrm>
-            <a:off x="713232" y="4288536"/>
-            <a:ext cx="365760" cy="365760"/>
-          </a:xfrm>
-          <a:prstGeom prst="ellipse">
-            <a:avLst/>
-          </a:prstGeom>
-          <a:solidFill>
-            <a:srgbClr val="16A34A"/>
-          </a:solidFill>
-          <a:ln/>
-        </p:spPr>
-        <p:txBody>
-          <a:bodyPr/>
-          <a:p/>
-        </p:txBody>
-      </p:sp>
-      <p:sp>
-        <p:nvSpPr>
-          <p:cNvPr id="26" name="Text 24"/>
-          <p:cNvSpPr txBox="1"/>
-          <p:nvPr/>
-        </p:nvSpPr>
-        <p:spPr>
-          <a:xfrm>
-            <a:off x="713232" y="4288536"/>
-            <a:ext cx="365760" cy="365760"/>
-          </a:xfrm>
-          <a:prstGeom prst="rect">
-            <a:avLst/>
-          </a:prstGeom>
-          <a:noFill/>
-          <a:ln/>
-        </p:spPr>
-        <p:txBody>
-          <a:bodyPr wrap="square" lIns="0" tIns="0" rIns="0" bIns="0" rtlCol="0" anchor="ctr"/>
-          <a:lstStyle/>
-          <a:p>
-            <a:pPr algn="ctr" indent="0" marL="0">
-              <a:buNone/>
-            </a:pPr>
-            <a:r>
-              <a:rPr lang="en-US" sz="1600" b="1" dirty="0">
-                <a:solidFill>
-                  <a:srgbClr val="FFFFFF"/>
-                </a:solidFill>
-                <a:latin typeface="Cambria" pitchFamily="34" charset="0"/>
-                <a:ea typeface="Cambria" pitchFamily="34" charset="-122"/>
-                <a:cs typeface="Cambria" pitchFamily="34" charset="-120"/>
-              </a:rPr>
-              <a:t>✓</a:t>
-            </a:r>
-            <a:endParaRPr lang="en-US" sz="1600" dirty="0"/>
-          </a:p>
-        </p:txBody>
-      </p:sp>
-      <p:sp>
-        <p:nvSpPr>
-          <p:cNvPr id="27" name="Text 25"/>
-          <p:cNvSpPr txBox="1"/>
-          <p:nvPr/>
-        </p:nvSpPr>
-        <p:spPr>
-          <a:xfrm>
-            <a:off x="1234440" y="4215384"/>
-            <a:ext cx="4526280" cy="320040"/>
-          </a:xfrm>
-          <a:prstGeom prst="rect">
-            <a:avLst/>
-          </a:prstGeom>
-          <a:noFill/>
-          <a:ln/>
-        </p:spPr>
-        <p:txBody>
-          <a:bodyPr wrap="square" lIns="0" tIns="0" rIns="0" bIns="0" rtlCol="0" anchor="ctr"/>
-          <a:lstStyle/>
-          <a:p>
-            <a:pPr indent="0" marL="0">
-              <a:buNone/>
-            </a:pPr>
-            <a:r>
-              <a:rPr lang="en-US" sz="1300" b="1" dirty="0">
-                <a:solidFill>
-                  <a:srgbClr val="FFFFFF"/>
-                </a:solidFill>
-                <a:latin typeface="Calibri" pitchFamily="34" charset="0"/>
-                <a:ea typeface="Calibri" pitchFamily="34" charset="-122"/>
-                <a:cs typeface="Calibri" pitchFamily="34" charset="-120"/>
-              </a:rPr>
-              <a:t>Security headers &amp; cookies</a:t>
-            </a:r>
-            <a:endParaRPr lang="en-US" sz="1300" dirty="0"/>
-          </a:p>
-        </p:txBody>
-      </p:sp>
-      <p:sp>
-        <p:nvSpPr>
-          <p:cNvPr id="28" name="Text 26"/>
-          <p:cNvSpPr txBox="1"/>
-          <p:nvPr/>
-        </p:nvSpPr>
-        <p:spPr>
-          <a:xfrm>
-            <a:off x="1234440" y="4544568"/>
-            <a:ext cx="4526280" cy="548640"/>
-          </a:xfrm>
-          <a:prstGeom prst="rect">
-            <a:avLst/>
-          </a:prstGeom>
-          <a:noFill/>
-          <a:ln/>
-        </p:spPr>
-        <p:txBody>
-          <a:bodyPr wrap="square" lIns="0" tIns="0" rIns="0" bIns="0" rtlCol="0" anchor="ctr"/>
-          <a:lstStyle/>
-          <a:p>
-            <a:pPr indent="0" marL="0">
-              <a:buNone/>
-            </a:pPr>
-            <a:r>
-              <a:rPr lang="en-US" sz="1000" dirty="0">
-                <a:solidFill>
-                  <a:srgbClr val="CADCFC"/>
-                </a:solidFill>
-                <a:latin typeface="Calibri" pitchFamily="34" charset="0"/>
-                <a:ea typeface="Calibri" pitchFamily="34" charset="-122"/>
-                <a:cs typeface="Calibri" pitchFamily="34" charset="-120"/>
-              </a:rPr>
-              <a:t>Strict Content-Security-Policy with no inline code, no framing, HSTS, HttpOnly cookies</a:t>
-            </a:r>
-            <a:endParaRPr lang="en-US" sz="1000" dirty="0"/>
-          </a:p>
-        </p:txBody>
-      </p:sp>
-      <p:sp>
-        <p:nvSpPr>
-          <p:cNvPr id="29" name="Shape 27"/>
-          <p:cNvSpPr/>
-          <p:nvPr/>
-        </p:nvSpPr>
-        <p:spPr>
-          <a:xfrm>
-            <a:off x="6217920" y="4123944"/>
-            <a:ext cx="5394960" cy="1051560"/>
-          </a:xfrm>
-          <a:prstGeom prst="roundRect">
-            <a:avLst>
-              <a:gd name="adj" fmla="val 6957"/>
-            </a:avLst>
-          </a:prstGeom>
-          <a:solidFill>
-            <a:srgbClr val="1E293B"/>
-          </a:solidFill>
-          <a:ln/>
-        </p:spPr>
-        <p:txBody>
-          <a:bodyPr/>
-          <a:p/>
-        </p:txBody>
-      </p:sp>
-      <p:sp>
-        <p:nvSpPr>
-          <p:cNvPr id="30" name="Shape 28"/>
-          <p:cNvSpPr/>
-          <p:nvPr/>
-        </p:nvSpPr>
-        <p:spPr>
-          <a:xfrm>
-            <a:off x="6382512" y="4288536"/>
-            <a:ext cx="365760" cy="365760"/>
-          </a:xfrm>
-          <a:prstGeom prst="ellipse">
-            <a:avLst/>
-          </a:prstGeom>
-          <a:solidFill>
-            <a:srgbClr val="16A34A"/>
-          </a:solidFill>
-          <a:ln/>
-        </p:spPr>
-        <p:txBody>
-          <a:bodyPr/>
-          <a:p/>
-        </p:txBody>
-      </p:sp>
-      <p:sp>
-        <p:nvSpPr>
-          <p:cNvPr id="31" name="Text 29"/>
-          <p:cNvSpPr txBox="1"/>
-          <p:nvPr/>
-        </p:nvSpPr>
-        <p:spPr>
-          <a:xfrm>
-            <a:off x="6382512" y="4288536"/>
-            <a:ext cx="365760" cy="365760"/>
-          </a:xfrm>
-          <a:prstGeom prst="rect">
-            <a:avLst/>
-          </a:prstGeom>
-          <a:noFill/>
-          <a:ln/>
-        </p:spPr>
-        <p:txBody>
-          <a:bodyPr wrap="square" lIns="0" tIns="0" rIns="0" bIns="0" rtlCol="0" anchor="ctr"/>
-          <a:lstStyle/>
-          <a:p>
-            <a:pPr algn="ctr" indent="0" marL="0">
-              <a:buNone/>
-            </a:pPr>
-            <a:r>
-              <a:rPr lang="en-US" sz="1600" b="1" dirty="0">
-                <a:solidFill>
-                  <a:srgbClr val="FFFFFF"/>
-                </a:solidFill>
-                <a:latin typeface="Cambria" pitchFamily="34" charset="0"/>
-                <a:ea typeface="Cambria" pitchFamily="34" charset="-122"/>
-                <a:cs typeface="Cambria" pitchFamily="34" charset="-120"/>
-              </a:rPr>
-              <a:t>✓</a:t>
-            </a:r>
-            <a:endParaRPr lang="en-US" sz="1600" dirty="0"/>
-          </a:p>
-        </p:txBody>
-      </p:sp>
-      <p:sp>
-        <p:nvSpPr>
-          <p:cNvPr id="32" name="Text 30"/>
-          <p:cNvSpPr txBox="1"/>
-          <p:nvPr/>
-        </p:nvSpPr>
-        <p:spPr>
-          <a:xfrm>
-            <a:off x="6903720" y="4215384"/>
-            <a:ext cx="4526280" cy="320040"/>
-          </a:xfrm>
-          <a:prstGeom prst="rect">
-            <a:avLst/>
-          </a:prstGeom>
-          <a:noFill/>
-          <a:ln/>
-        </p:spPr>
-        <p:txBody>
-          <a:bodyPr wrap="square" lIns="0" tIns="0" rIns="0" bIns="0" rtlCol="0" anchor="ctr"/>
-          <a:lstStyle/>
-          <a:p>
-            <a:pPr indent="0" marL="0">
-              <a:buNone/>
-            </a:pPr>
-            <a:r>
-              <a:rPr lang="en-US" sz="1300" b="1" dirty="0">
-                <a:solidFill>
-                  <a:srgbClr val="FFFFFF"/>
-                </a:solidFill>
-                <a:latin typeface="Calibri" pitchFamily="34" charset="0"/>
-                <a:ea typeface="Calibri" pitchFamily="34" charset="-122"/>
-                <a:cs typeface="Calibri" pitchFamily="34" charset="-120"/>
-              </a:rPr>
-              <a:t>No default secret key</a:t>
-            </a:r>
-            <a:endParaRPr lang="en-US" sz="1300" dirty="0"/>
-          </a:p>
-        </p:txBody>
-      </p:sp>
-      <p:sp>
-        <p:nvSpPr>
-          <p:cNvPr id="33" name="Text 31"/>
-          <p:cNvSpPr txBox="1"/>
-          <p:nvPr/>
-        </p:nvSpPr>
-        <p:spPr>
-          <a:xfrm>
-            <a:off x="6903720" y="4544568"/>
-            <a:ext cx="4526280" cy="548640"/>
-          </a:xfrm>
-          <a:prstGeom prst="rect">
-            <a:avLst/>
-          </a:prstGeom>
-          <a:noFill/>
-          <a:ln/>
-        </p:spPr>
-        <p:txBody>
-          <a:bodyPr wrap="square" lIns="0" tIns="0" rIns="0" bIns="0" rtlCol="0" anchor="ctr"/>
-          <a:lstStyle/>
-          <a:p>
-            <a:pPr indent="0" marL="0">
-              <a:buNone/>
-            </a:pPr>
-            <a:r>
-              <a:rPr lang="en-US" sz="1000" dirty="0">
-                <a:solidFill>
-                  <a:srgbClr val="CADCFC"/>
-                </a:solidFill>
-                <a:latin typeface="Calibri" pitchFamily="34" charset="0"/>
-                <a:ea typeface="Calibri" pitchFamily="34" charset="-122"/>
-                <a:cs typeface="Calibri" pitchFamily="34" charset="-120"/>
-              </a:rPr>
-              <a:t>The app refuses to start with a missing or published SECRET_KEY</a:t>
-            </a:r>
-            <a:endParaRPr lang="en-US" sz="1000" dirty="0"/>
-          </a:p>
-        </p:txBody>
-      </p:sp>
-      <p:sp>
-        <p:nvSpPr>
-          <p:cNvPr id="34" name="Shape 32"/>
-          <p:cNvSpPr/>
-          <p:nvPr/>
-        </p:nvSpPr>
-        <p:spPr>
-          <a:xfrm>
-            <a:off x="548640" y="5340096"/>
-            <a:ext cx="5394960" cy="1051560"/>
-          </a:xfrm>
-          <a:prstGeom prst="roundRect">
-            <a:avLst>
-              <a:gd name="adj" fmla="val 6957"/>
-            </a:avLst>
-          </a:prstGeom>
-          <a:solidFill>
-            <a:srgbClr val="1E293B"/>
-          </a:solidFill>
-          <a:ln/>
-        </p:spPr>
-        <p:txBody>
-          <a:bodyPr/>
-          <a:p/>
-        </p:txBody>
-      </p:sp>
-      <p:sp>
-        <p:nvSpPr>
-          <p:cNvPr id="35" name="Shape 33"/>
-          <p:cNvSpPr/>
-          <p:nvPr/>
-        </p:nvSpPr>
-        <p:spPr>
-          <a:xfrm>
-            <a:off x="713232" y="5504688"/>
-            <a:ext cx="365760" cy="365760"/>
-          </a:xfrm>
-          <a:prstGeom prst="ellipse">
-            <a:avLst/>
-          </a:prstGeom>
-          <a:solidFill>
-            <a:srgbClr val="16A34A"/>
-          </a:solidFill>
-          <a:ln/>
-        </p:spPr>
-        <p:txBody>
-          <a:bodyPr/>
-          <a:p/>
-        </p:txBody>
-      </p:sp>
-      <p:sp>
-        <p:nvSpPr>
-          <p:cNvPr id="36" name="Text 34"/>
-          <p:cNvSpPr txBox="1"/>
-          <p:nvPr/>
-        </p:nvSpPr>
-        <p:spPr>
-          <a:xfrm>
-            <a:off x="713232" y="5504688"/>
-            <a:ext cx="365760" cy="365760"/>
-          </a:xfrm>
-          <a:prstGeom prst="rect">
-            <a:avLst/>
-          </a:prstGeom>
-          <a:noFill/>
-          <a:ln/>
-        </p:spPr>
-        <p:txBody>
-          <a:bodyPr wrap="square" lIns="0" tIns="0" rIns="0" bIns="0" rtlCol="0" anchor="ctr"/>
-          <a:lstStyle/>
-          <a:p>
-            <a:pPr algn="ctr" indent="0" marL="0">
-              <a:buNone/>
-            </a:pPr>
-            <a:r>
-              <a:rPr lang="en-US" sz="1600" b="1" dirty="0">
-                <a:solidFill>
-                  <a:srgbClr val="FFFFFF"/>
-                </a:solidFill>
-                <a:latin typeface="Cambria" pitchFamily="34" charset="0"/>
-                <a:ea typeface="Cambria" pitchFamily="34" charset="-122"/>
-                <a:cs typeface="Cambria" pitchFamily="34" charset="-120"/>
-              </a:rPr>
-              <a:t>✓</a:t>
-            </a:r>
-            <a:endParaRPr lang="en-US" sz="1600" dirty="0"/>
-          </a:p>
-        </p:txBody>
-      </p:sp>
-      <p:sp>
-        <p:nvSpPr>
-          <p:cNvPr id="37" name="Text 35"/>
-          <p:cNvSpPr txBox="1"/>
-          <p:nvPr/>
-        </p:nvSpPr>
-        <p:spPr>
-          <a:xfrm>
-            <a:off x="1234440" y="5431536"/>
-            <a:ext cx="4526280" cy="320040"/>
-          </a:xfrm>
-          <a:prstGeom prst="rect">
-            <a:avLst/>
-          </a:prstGeom>
-          <a:noFill/>
-          <a:ln/>
-        </p:spPr>
-        <p:txBody>
-          <a:bodyPr wrap="square" lIns="0" tIns="0" rIns="0" bIns="0" rtlCol="0" anchor="ctr"/>
-          <a:lstStyle/>
-          <a:p>
-            <a:pPr indent="0" marL="0">
-              <a:buNone/>
-            </a:pPr>
-            <a:r>
-              <a:rPr lang="en-US" sz="1300" b="1" dirty="0">
-                <a:solidFill>
-                  <a:srgbClr val="FFFFFF"/>
-                </a:solidFill>
-                <a:latin typeface="Calibri" pitchFamily="34" charset="0"/>
-                <a:ea typeface="Calibri" pitchFamily="34" charset="-122"/>
-                <a:cs typeface="Calibri" pitchFamily="34" charset="-120"/>
-              </a:rPr>
-              <a:t>Database migrations</a:t>
-            </a:r>
-            <a:endParaRPr lang="en-US" sz="1300" dirty="0"/>
-          </a:p>
-        </p:txBody>
-      </p:sp>
-      <p:sp>
-        <p:nvSpPr>
-          <p:cNvPr id="38" name="Text 36"/>
-          <p:cNvSpPr txBox="1"/>
-          <p:nvPr/>
-        </p:nvSpPr>
-        <p:spPr>
-          <a:xfrm>
-            <a:off x="1234440" y="5760720"/>
-            <a:ext cx="4526280" cy="548640"/>
-          </a:xfrm>
-          <a:prstGeom prst="rect">
-            <a:avLst/>
-          </a:prstGeom>
-          <a:noFill/>
-          <a:ln/>
-        </p:spPr>
-        <p:txBody>
-          <a:bodyPr wrap="square" lIns="0" tIns="0" rIns="0" bIns="0" rtlCol="0" anchor="ctr"/>
-          <a:lstStyle/>
-          <a:p>
-            <a:pPr indent="0" marL="0">
-              <a:buNone/>
-            </a:pPr>
-            <a:r>
-              <a:rPr lang="en-US" sz="1000" dirty="0">
-                <a:solidFill>
-                  <a:srgbClr val="CADCFC"/>
-                </a:solidFill>
-                <a:latin typeface="Calibri" pitchFamily="34" charset="0"/>
-                <a:ea typeface="Calibri" pitchFamily="34" charset="-122"/>
-                <a:cs typeface="Calibri" pitchFamily="34" charset="-120"/>
-              </a:rPr>
-              <a:t>Alembic replaces create_all(); older databases are adopted with their data</a:t>
-            </a:r>
-            <a:endParaRPr lang="en-US" sz="1000" dirty="0"/>
-          </a:p>
-        </p:txBody>
-      </p:sp>
-      <p:sp>
-        <p:nvSpPr>
-          <p:cNvPr id="39" name="Shape 37"/>
-          <p:cNvSpPr/>
-          <p:nvPr/>
-        </p:nvSpPr>
-        <p:spPr>
-          <a:xfrm>
-            <a:off x="6217920" y="5340096"/>
-            <a:ext cx="5394960" cy="1051560"/>
-          </a:xfrm>
-          <a:prstGeom prst="roundRect">
-            <a:avLst>
-              <a:gd name="adj" fmla="val 6957"/>
-            </a:avLst>
-          </a:prstGeom>
-          <a:solidFill>
-            <a:srgbClr val="1E293B"/>
-          </a:solidFill>
-          <a:ln/>
-        </p:spPr>
-        <p:txBody>
-          <a:bodyPr/>
-          <a:p/>
-        </p:txBody>
-      </p:sp>
-      <p:sp>
-        <p:nvSpPr>
-          <p:cNvPr id="40" name="Shape 38"/>
-          <p:cNvSpPr/>
-          <p:nvPr/>
-        </p:nvSpPr>
-        <p:spPr>
-          <a:xfrm>
-            <a:off x="6382512" y="5504688"/>
-            <a:ext cx="365760" cy="365760"/>
-          </a:xfrm>
-          <a:prstGeom prst="ellipse">
-            <a:avLst/>
-          </a:prstGeom>
-          <a:solidFill>
-            <a:srgbClr val="16A34A"/>
-          </a:solidFill>
-          <a:ln/>
-        </p:spPr>
-        <p:txBody>
-          <a:bodyPr/>
-          <a:p/>
-        </p:txBody>
-      </p:sp>
-      <p:sp>
-        <p:nvSpPr>
-          <p:cNvPr id="41" name="Text 39"/>
-          <p:cNvSpPr txBox="1"/>
-          <p:nvPr/>
-        </p:nvSpPr>
-        <p:spPr>
-          <a:xfrm>
-            <a:off x="6382512" y="5504688"/>
-            <a:ext cx="365760" cy="365760"/>
-          </a:xfrm>
-          <a:prstGeom prst="rect">
-            <a:avLst/>
-          </a:prstGeom>
-          <a:noFill/>
-          <a:ln/>
-        </p:spPr>
-        <p:txBody>
-          <a:bodyPr wrap="square" lIns="0" tIns="0" rIns="0" bIns="0" rtlCol="0" anchor="ctr"/>
-          <a:lstStyle/>
-          <a:p>
-            <a:pPr algn="ctr" indent="0" marL="0">
-              <a:buNone/>
-            </a:pPr>
-            <a:r>
-              <a:rPr lang="en-US" sz="1600" b="1" dirty="0">
-                <a:solidFill>
-                  <a:srgbClr val="FFFFFF"/>
-                </a:solidFill>
-                <a:latin typeface="Cambria" pitchFamily="34" charset="0"/>
-                <a:ea typeface="Cambria" pitchFamily="34" charset="-122"/>
-                <a:cs typeface="Cambria" pitchFamily="34" charset="-120"/>
-              </a:rPr>
-              <a:t>✓</a:t>
-            </a:r>
-            <a:endParaRPr lang="en-US" sz="1600" dirty="0"/>
-          </a:p>
-        </p:txBody>
-      </p:sp>
-      <p:sp>
-        <p:nvSpPr>
-          <p:cNvPr id="42" name="Text 40"/>
-          <p:cNvSpPr txBox="1"/>
-          <p:nvPr/>
-        </p:nvSpPr>
-        <p:spPr>
-          <a:xfrm>
-            <a:off x="6903720" y="5431536"/>
-            <a:ext cx="4526280" cy="320040"/>
-          </a:xfrm>
-          <a:prstGeom prst="rect">
-            <a:avLst/>
-          </a:prstGeom>
-          <a:noFill/>
-          <a:ln/>
-        </p:spPr>
-        <p:txBody>
-          <a:bodyPr wrap="square" lIns="0" tIns="0" rIns="0" bIns="0" rtlCol="0" anchor="ctr"/>
-          <a:lstStyle/>
-          <a:p>
-            <a:pPr indent="0" marL="0">
-              <a:buNone/>
-            </a:pPr>
-            <a:r>
-              <a:rPr lang="en-US" sz="1300" b="1" dirty="0">
-                <a:solidFill>
-                  <a:srgbClr val="FFFFFF"/>
-                </a:solidFill>
-                <a:latin typeface="Calibri" pitchFamily="34" charset="0"/>
-                <a:ea typeface="Calibri" pitchFamily="34" charset="-122"/>
-                <a:cs typeface="Calibri" pitchFamily="34" charset="-120"/>
-              </a:rPr>
-              <a:t>Cloud file storage</a:t>
-            </a:r>
-            <a:endParaRPr lang="en-US" sz="1300" dirty="0"/>
-          </a:p>
-        </p:txBody>
-      </p:sp>
-      <p:sp>
-        <p:nvSpPr>
-          <p:cNvPr id="43" name="Text 41"/>
-          <p:cNvSpPr txBox="1"/>
-          <p:nvPr/>
-        </p:nvSpPr>
-        <p:spPr>
-          <a:xfrm>
-            <a:off x="6903720" y="5760720"/>
-            <a:ext cx="4526280" cy="548640"/>
-          </a:xfrm>
-          <a:prstGeom prst="rect">
-            <a:avLst/>
-          </a:prstGeom>
-          <a:noFill/>
-          <a:ln/>
-        </p:spPr>
-        <p:txBody>
-          <a:bodyPr wrap="square" lIns="0" tIns="0" rIns="0" bIns="0" rtlCol="0" anchor="ctr"/>
-          <a:lstStyle/>
-          <a:p>
-            <a:pPr indent="0" marL="0">
-              <a:buNone/>
-            </a:pPr>
-            <a:r>
-              <a:rPr lang="en-US" sz="1000" dirty="0">
-                <a:solidFill>
-                  <a:srgbClr val="CADCFC"/>
-                </a:solidFill>
-                <a:latin typeface="Calibri" pitchFamily="34" charset="0"/>
-                <a:ea typeface="Calibri" pitchFamily="34" charset="-122"/>
-                <a:cs typeface="Calibri" pitchFamily="34" charset="-120"/>
-              </a:rPr>
-              <a:t>Uploads can live in an S3-compatible bucket and survive redeploys</a:t>
-            </a:r>
-            <a:endParaRPr lang="en-US" sz="1000" dirty="0"/>
-          </a:p>
-        </p:txBody>
-      </p:sp>
-      <p:sp>
-        <p:nvSpPr>
-          <p:cNvPr id="44" name="Text 42"/>
-          <p:cNvSpPr txBox="1"/>
-          <p:nvPr/>
-        </p:nvSpPr>
-        <p:spPr>
-          <a:xfrm>
-            <a:off x="457200" y="6528816"/>
-            <a:ext cx="7315200" cy="274320"/>
-          </a:xfrm>
-          <a:prstGeom prst="rect">
-            <a:avLst/>
-          </a:prstGeom>
-          <a:noFill/>
-          <a:ln/>
-        </p:spPr>
-        <p:txBody>
-          <a:bodyPr wrap="square" lIns="0" tIns="0" rIns="0" bIns="0" rtlCol="0" anchor="ctr"/>
-          <a:lstStyle/>
-          <a:p>
-            <a:pPr indent="0" marL="0">
-              <a:buNone/>
-            </a:pPr>
-            <a:r>
-              <a:rPr lang="en-US" sz="1000" dirty="0">
-                <a:solidFill>
-                  <a:srgbClr val="475569"/>
-                </a:solidFill>
-                <a:latin typeface="Calibri" pitchFamily="34" charset="0"/>
-                <a:ea typeface="Calibri" pitchFamily="34" charset="-122"/>
-                <a:cs typeface="Calibri" pitchFamily="34" charset="-120"/>
-              </a:rPr>
-              <a:t>Extended Scope — Full Arabic &amp; Hardening</a:t>
-            </a:r>
-            <a:endParaRPr lang="en-US" sz="1000" dirty="0"/>
-          </a:p>
-        </p:txBody>
-      </p:sp>
-      <p:sp>
-        <p:nvSpPr>
-          <p:cNvPr id="45" name="Text 43"/>
-          <p:cNvSpPr txBox="1"/>
-          <p:nvPr/>
-        </p:nvSpPr>
-        <p:spPr>
-          <a:xfrm>
-            <a:off x="11247120" y="6528816"/>
-            <a:ext cx="548640" cy="274320"/>
-          </a:xfrm>
-          <a:prstGeom prst="rect">
-            <a:avLst/>
-          </a:prstGeom>
-          <a:noFill/>
-          <a:ln/>
-        </p:spPr>
-        <p:txBody>
-          <a:bodyPr wrap="square" lIns="0" tIns="0" rIns="0" bIns="0" rtlCol="0" anchor="ctr"/>
-          <a:lstStyle/>
-          <a:p>
-            <a:pPr algn="r" indent="0" marL="0">
-              <a:buNone/>
-            </a:pPr>
-            <a:r>
-              <a:rPr lang="en-US" sz="1000" dirty="0">
-                <a:solidFill>
-                  <a:srgbClr val="475569"/>
-                </a:solidFill>
-                <a:latin typeface="Calibri" pitchFamily="34" charset="0"/>
-                <a:ea typeface="Calibri" pitchFamily="34" charset="-122"/>
-                <a:cs typeface="Calibri" pitchFamily="34" charset="-120"/>
-              </a:rPr>
-              <a:t>11 / 19</a:t>
-            </a:r>
-            <a:endParaRPr lang="en-US" sz="1000" dirty="0"/>
           </a:p>
         </p:txBody>
       </p:sp>
@@ -18975,7 +18973,7 @@
                 <a:ea typeface="Calibri" pitchFamily="34" charset="-122"/>
                 <a:cs typeface="Calibri" pitchFamily="34" charset="-120"/>
               </a:rPr>
-              <a:t>Eight gaps closed against the SRS after the Deliverable 3 prototype — every one covered by an automated test.</a:t>
+              <a:t>Eleven gaps closed against the SRS after the Deliverable 3 prototype, grouped here into eight areas — every one covered by an automated test.</a:t>
             </a:r>
             <a:endParaRPr lang="en-US" sz="1350" dirty="0"/>
           </a:p>
@@ -19270,7 +19268,7 @@
                 <a:ea typeface="Calibri" pitchFamily="34" charset="-122"/>
                 <a:cs typeface="Calibri" pitchFamily="34" charset="-120"/>
               </a:rPr>
-              <a:t>Configurable late fees</a:t>
+              <a:t>Unit editing</a:t>
             </a:r>
             <a:endParaRPr lang="en-US" sz="1300" dirty="0"/>
           </a:p>
@@ -19309,7 +19307,7 @@
                 <a:ea typeface="Calibri" pitchFamily="34" charset="-122"/>
                 <a:cs typeface="Calibri" pitchFamily="34" charset="-120"/>
               </a:rPr>
-              <a:t>Fixed or percentage, applied automatically once rent is overdue</a:t>
+              <a:t>Edit a unit’s details and status after it is created — previously units could only be added</a:t>
             </a:r>
             <a:endParaRPr lang="en-US" sz="1000" dirty="0"/>
           </a:p>
@@ -19437,7 +19435,7 @@
                 <a:ea typeface="Calibri" pitchFamily="34" charset="-122"/>
                 <a:cs typeface="Calibri" pitchFamily="34" charset="-120"/>
               </a:rPr>
-              <a:t>Tenant blacklisting</a:t>
+              <a:t>Configurable late fees</a:t>
             </a:r>
             <a:endParaRPr lang="en-US" sz="1300" dirty="0"/>
           </a:p>
@@ -19476,7 +19474,7 @@
                 <a:ea typeface="Calibri" pitchFamily="34" charset="-122"/>
                 <a:cs typeface="Calibri" pitchFamily="34" charset="-120"/>
               </a:rPr>
-              <a:t>Flag a tenant to block future leases without touching an existing one</a:t>
+              <a:t>Fixed or percentage, applied automatically once rent is overdue</a:t>
             </a:r>
             <a:endParaRPr lang="en-US" sz="1000" dirty="0"/>
           </a:p>
@@ -19604,7 +19602,7 @@
                 <a:ea typeface="Calibri" pitchFamily="34" charset="-122"/>
                 <a:cs typeface="Calibri" pitchFamily="34" charset="-120"/>
               </a:rPr>
-              <a:t>Tenant ID documents</a:t>
+              <a:t>Tenant blacklisting</a:t>
             </a:r>
             <a:endParaRPr lang="en-US" sz="1300" dirty="0"/>
           </a:p>
@@ -19643,7 +19641,7 @@
                 <a:ea typeface="Calibri" pitchFamily="34" charset="-122"/>
                 <a:cs typeface="Calibri" pitchFamily="34" charset="-120"/>
               </a:rPr>
-              <a:t>Upload and securely serve a tenant’s identification</a:t>
+              <a:t>Flag a tenant to block future leases without touching an existing one</a:t>
             </a:r>
             <a:endParaRPr lang="en-US" sz="1000" dirty="0"/>
           </a:p>
@@ -19771,7 +19769,7 @@
                 <a:ea typeface="Calibri" pitchFamily="34" charset="-122"/>
                 <a:cs typeface="Calibri" pitchFamily="34" charset="-120"/>
               </a:rPr>
-              <a:t>Admin user console</a:t>
+              <a:t>Tenant &amp; lease documents</a:t>
             </a:r>
             <a:endParaRPr lang="en-US" sz="1300" dirty="0"/>
           </a:p>
@@ -19810,7 +19808,7 @@
                 <a:ea typeface="Calibri" pitchFamily="34" charset="-122"/>
                 <a:cs typeface="Calibri" pitchFamily="34" charset="-120"/>
               </a:rPr>
-              <a:t>Role &amp; status management with an “at least one active Owner” guard</a:t>
+              <a:t>Upload a tenant’s ID; download a lease PDF as management or as the tenant</a:t>
             </a:r>
             <a:endParaRPr lang="en-US" sz="1000" dirty="0"/>
           </a:p>
@@ -19938,7 +19936,7 @@
                 <a:ea typeface="Calibri" pitchFamily="34" charset="-122"/>
                 <a:cs typeface="Calibri" pitchFamily="34" charset="-120"/>
               </a:rPr>
-              <a:t>Staff self-service accounts</a:t>
+              <a:t>Admin user console</a:t>
             </a:r>
             <a:endParaRPr lang="en-US" sz="1300" dirty="0"/>
           </a:p>
@@ -19977,7 +19975,7 @@
                 <a:ea typeface="Calibri" pitchFamily="34" charset="-122"/>
                 <a:cs typeface="Calibri" pitchFamily="34" charset="-120"/>
               </a:rPr>
-              <a:t>Owner/Manager/Admin can create a Maintenance Staff login directly</a:t>
+              <a:t>Role &amp; status management with an “at least one active Owner” guard</a:t>
             </a:r>
             <a:endParaRPr lang="en-US" sz="1000" dirty="0"/>
           </a:p>
@@ -20105,7 +20103,7 @@
                 <a:ea typeface="Calibri" pitchFamily="34" charset="-122"/>
                 <a:cs typeface="Calibri" pitchFamily="34" charset="-120"/>
               </a:rPr>
-              <a:t>CSV rent history export</a:t>
+              <a:t>Staff self-service accounts</a:t>
             </a:r>
             <a:endParaRPr lang="en-US" sz="1300" dirty="0"/>
           </a:p>
@@ -20144,7 +20142,7 @@
                 <a:ea typeface="Calibri" pitchFamily="34" charset="-122"/>
                 <a:cs typeface="Calibri" pitchFamily="34" charset="-120"/>
               </a:rPr>
-              <a:t>One-click spreadsheet export of a lease’s payment history</a:t>
+              <a:t>Owner/Manager/Admin can create a Maintenance Staff login directly</a:t>
             </a:r>
             <a:endParaRPr lang="en-US" sz="1000" dirty="0"/>
           </a:p>
@@ -20272,7 +20270,7 @@
                 <a:ea typeface="Calibri" pitchFamily="34" charset="-122"/>
                 <a:cs typeface="Calibri" pitchFamily="34" charset="-120"/>
               </a:rPr>
-              <a:t>Excel portfolio export</a:t>
+              <a:t>CSV &amp; Excel exports</a:t>
             </a:r>
             <a:endParaRPr lang="en-US" sz="1300" dirty="0"/>
           </a:p>
@@ -20311,7 +20309,7 @@
                 <a:ea typeface="Calibri" pitchFamily="34" charset="-122"/>
                 <a:cs typeface="Calibri" pitchFamily="34" charset="-120"/>
               </a:rPr>
-              <a:t>Two-sheet .xlsx workbook: portfolio summary + per-property breakdown</a:t>
+              <a:t>A lease’s payment history as CSV; a two-sheet .xlsx portfolio workbook</a:t>
             </a:r>
             <a:endParaRPr lang="en-US" sz="1000" dirty="0"/>
           </a:p>

</xml_diff>